<commit_message>
Modifications to Scenario #1
</commit_message>
<xml_diff>
--- a/01 - Documents and Preparation/Accelerate your T-SQL Code.pptx
+++ b/01 - Documents and Preparation/Accelerate your T-SQL Code.pptx
@@ -10,13 +10,13 @@
   </p:notesMasterIdLst>
   <p:sldIdLst>
     <p:sldId id="334" r:id="rId3"/>
-    <p:sldId id="262" r:id="rId4"/>
-    <p:sldId id="335" r:id="rId5"/>
-    <p:sldId id="297" r:id="rId6"/>
-    <p:sldId id="349" r:id="rId7"/>
-    <p:sldId id="256" r:id="rId8"/>
-    <p:sldId id="336" r:id="rId9"/>
-    <p:sldId id="337" r:id="rId10"/>
+    <p:sldId id="335" r:id="rId4"/>
+    <p:sldId id="297" r:id="rId5"/>
+    <p:sldId id="349" r:id="rId6"/>
+    <p:sldId id="256" r:id="rId7"/>
+    <p:sldId id="336" r:id="rId8"/>
+    <p:sldId id="337" r:id="rId9"/>
+    <p:sldId id="431" r:id="rId10"/>
     <p:sldId id="338" r:id="rId11"/>
     <p:sldId id="342" r:id="rId12"/>
     <p:sldId id="339" r:id="rId13"/>
@@ -154,7 +154,7 @@
 <file path=ppt/revisionInfo.xml><?xml version="1.0" encoding="utf-8"?>
 <p1510:revInfo xmlns:a="http://schemas.openxmlformats.org/drawingml/2006/main" xmlns:r="http://schemas.openxmlformats.org/officeDocument/2006/relationships" xmlns:p1510="http://schemas.microsoft.com/office/powerpoint/2015/10/main">
   <p1510:revLst>
-    <p1510:client id="{92F929E2-2F38-4667-BA7A-90B36F7C61D2}" v="16" dt="2026-05-28T03:58:31.620"/>
+    <p1510:client id="{B4A5CE1A-760E-4FE6-9DA0-4AA372CE281A}" v="2" dt="2026-09-21T08:08:55.453"/>
   </p1510:revLst>
 </p1510:revInfo>
 </file>
@@ -164,63 +164,18 @@
   <pc:docChgLst>
     <pc:chgData name="Uwe Ricken" userId="f02567aecbed924b" providerId="LiveId" clId="{E77B627B-1F43-41A9-9F24-D4BB31BF6050}"/>
     <pc:docChg chg="undo custSel addSld delSld modSld">
-      <pc:chgData name="Uwe Ricken" userId="f02567aecbed924b" providerId="LiveId" clId="{E77B627B-1F43-41A9-9F24-D4BB31BF6050}" dt="2026-05-28T03:58:31.620" v="717"/>
+      <pc:chgData name="Uwe Ricken" userId="f02567aecbed924b" providerId="LiveId" clId="{E77B627B-1F43-41A9-9F24-D4BB31BF6050}" dt="2026-09-21T07:57:24.855" v="983" actId="20577"/>
       <pc:docMkLst>
         <pc:docMk/>
       </pc:docMkLst>
-      <pc:sldChg chg="add">
-        <pc:chgData name="Uwe Ricken" userId="f02567aecbed924b" providerId="LiveId" clId="{E77B627B-1F43-41A9-9F24-D4BB31BF6050}" dt="2026-05-28T03:58:31.620" v="717"/>
-        <pc:sldMkLst>
-          <pc:docMk/>
-          <pc:sldMk cId="1665617814" sldId="262"/>
-        </pc:sldMkLst>
-      </pc:sldChg>
       <pc:sldChg chg="modSp mod">
-        <pc:chgData name="Uwe Ricken" userId="f02567aecbed924b" providerId="LiveId" clId="{E77B627B-1F43-41A9-9F24-D4BB31BF6050}" dt="2026-05-28T03:43:52.972" v="228" actId="20577"/>
-        <pc:sldMkLst>
-          <pc:docMk/>
-          <pc:sldMk cId="1817427835" sldId="341"/>
-        </pc:sldMkLst>
-        <pc:spChg chg="mod">
-          <ac:chgData name="Uwe Ricken" userId="f02567aecbed924b" providerId="LiveId" clId="{E77B627B-1F43-41A9-9F24-D4BB31BF6050}" dt="2026-05-28T03:43:52.972" v="228" actId="20577"/>
-          <ac:spMkLst>
-            <pc:docMk/>
-            <pc:sldMk cId="1817427835" sldId="341"/>
-            <ac:spMk id="3" creationId="{E5CD2D06-DE0C-4810-E268-11D021E21C77}"/>
-          </ac:spMkLst>
-        </pc:spChg>
-      </pc:sldChg>
-      <pc:sldChg chg="modSp mod">
-        <pc:chgData name="Uwe Ricken" userId="f02567aecbed924b" providerId="LiveId" clId="{E77B627B-1F43-41A9-9F24-D4BB31BF6050}" dt="2026-05-27T14:20:15.862" v="7" actId="20577"/>
-        <pc:sldMkLst>
-          <pc:docMk/>
-          <pc:sldMk cId="3652038028" sldId="345"/>
-        </pc:sldMkLst>
-        <pc:spChg chg="mod">
-          <ac:chgData name="Uwe Ricken" userId="f02567aecbed924b" providerId="LiveId" clId="{E77B627B-1F43-41A9-9F24-D4BB31BF6050}" dt="2026-05-27T14:20:15.862" v="7" actId="20577"/>
-          <ac:spMkLst>
-            <pc:docMk/>
-            <pc:sldMk cId="3652038028" sldId="345"/>
-            <ac:spMk id="5" creationId="{0F6657EA-C526-1DA9-88E9-04AC462B1B78}"/>
-          </ac:spMkLst>
-        </pc:spChg>
-      </pc:sldChg>
-      <pc:sldChg chg="modSp mod">
-        <pc:chgData name="Uwe Ricken" userId="f02567aecbed924b" providerId="LiveId" clId="{E77B627B-1F43-41A9-9F24-D4BB31BF6050}" dt="2026-05-28T03:44:41.304" v="230" actId="20577"/>
+        <pc:chgData name="Uwe Ricken" userId="f02567aecbed924b" providerId="LiveId" clId="{E77B627B-1F43-41A9-9F24-D4BB31BF6050}" dt="2026-09-21T07:57:24.855" v="983" actId="20577"/>
         <pc:sldMkLst>
           <pc:docMk/>
           <pc:sldMk cId="1275382174" sldId="346"/>
         </pc:sldMkLst>
         <pc:spChg chg="mod">
-          <ac:chgData name="Uwe Ricken" userId="f02567aecbed924b" providerId="LiveId" clId="{E77B627B-1F43-41A9-9F24-D4BB31BF6050}" dt="2026-05-28T03:44:41.304" v="230" actId="20577"/>
-          <ac:spMkLst>
-            <pc:docMk/>
-            <pc:sldMk cId="1275382174" sldId="346"/>
-            <ac:spMk id="2" creationId="{116EB023-6951-7EFF-FE4D-2047F18A9DF8}"/>
-          </ac:spMkLst>
-        </pc:spChg>
-        <pc:spChg chg="mod">
-          <ac:chgData name="Uwe Ricken" userId="f02567aecbed924b" providerId="LiveId" clId="{E77B627B-1F43-41A9-9F24-D4BB31BF6050}" dt="2026-05-27T14:21:53.787" v="9" actId="20577"/>
+          <ac:chgData name="Uwe Ricken" userId="f02567aecbed924b" providerId="LiveId" clId="{E77B627B-1F43-41A9-9F24-D4BB31BF6050}" dt="2026-09-21T07:57:24.855" v="983" actId="20577"/>
           <ac:spMkLst>
             <pc:docMk/>
             <pc:sldMk cId="1275382174" sldId="346"/>
@@ -228,464 +183,44 @@
           </ac:spMkLst>
         </pc:spChg>
       </pc:sldChg>
-      <pc:sldChg chg="modSp mod">
-        <pc:chgData name="Uwe Ricken" userId="f02567aecbed924b" providerId="LiveId" clId="{E77B627B-1F43-41A9-9F24-D4BB31BF6050}" dt="2026-05-27T14:22:32.365" v="12" actId="20577"/>
+      <pc:sldChg chg="addSp delSp modSp new mod modClrScheme chgLayout">
+        <pc:chgData name="Uwe Ricken" userId="f02567aecbed924b" providerId="LiveId" clId="{E77B627B-1F43-41A9-9F24-D4BB31BF6050}" dt="2026-09-21T07:00:57.275" v="752" actId="20577"/>
         <pc:sldMkLst>
           <pc:docMk/>
-          <pc:sldMk cId="2156939699" sldId="347"/>
+          <pc:sldMk cId="542850919" sldId="431"/>
         </pc:sldMkLst>
-        <pc:spChg chg="mod">
-          <ac:chgData name="Uwe Ricken" userId="f02567aecbed924b" providerId="LiveId" clId="{E77B627B-1F43-41A9-9F24-D4BB31BF6050}" dt="2026-05-27T14:22:32.365" v="12" actId="20577"/>
+        <pc:spChg chg="del mod ord">
+          <ac:chgData name="Uwe Ricken" userId="f02567aecbed924b" providerId="LiveId" clId="{E77B627B-1F43-41A9-9F24-D4BB31BF6050}" dt="2026-09-21T06:59:22.667" v="726" actId="700"/>
           <ac:spMkLst>
             <pc:docMk/>
-            <pc:sldMk cId="2156939699" sldId="347"/>
-            <ac:spMk id="3" creationId="{3157281D-DF73-5D1C-793E-C5F1FC480217}"/>
+            <pc:sldMk cId="542850919" sldId="431"/>
+            <ac:spMk id="2" creationId="{67E19BAA-3FB4-064E-C1A1-C1EBAD9A8C41}"/>
           </ac:spMkLst>
         </pc:spChg>
-      </pc:sldChg>
-      <pc:sldChg chg="modSp mod">
-        <pc:chgData name="Uwe Ricken" userId="f02567aecbed924b" providerId="LiveId" clId="{E77B627B-1F43-41A9-9F24-D4BB31BF6050}" dt="2026-05-28T03:46:11.967" v="236" actId="20577"/>
-        <pc:sldMkLst>
-          <pc:docMk/>
-          <pc:sldMk cId="1743379650" sldId="351"/>
-        </pc:sldMkLst>
-        <pc:spChg chg="mod">
-          <ac:chgData name="Uwe Ricken" userId="f02567aecbed924b" providerId="LiveId" clId="{E77B627B-1F43-41A9-9F24-D4BB31BF6050}" dt="2026-05-28T03:46:11.967" v="236" actId="20577"/>
+        <pc:spChg chg="del mod ord">
+          <ac:chgData name="Uwe Ricken" userId="f02567aecbed924b" providerId="LiveId" clId="{E77B627B-1F43-41A9-9F24-D4BB31BF6050}" dt="2026-09-21T06:59:22.667" v="726" actId="700"/>
           <ac:spMkLst>
             <pc:docMk/>
-            <pc:sldMk cId="1743379650" sldId="351"/>
-            <ac:spMk id="4" creationId="{35A56122-B5DB-9476-584C-79DB6AD81415}"/>
+            <pc:sldMk cId="542850919" sldId="431"/>
+            <ac:spMk id="3" creationId="{534DC174-79A5-9666-021D-622EB97074E2}"/>
           </ac:spMkLst>
         </pc:spChg>
-      </pc:sldChg>
-      <pc:sldChg chg="modSp mod">
-        <pc:chgData name="Uwe Ricken" userId="f02567aecbed924b" providerId="LiveId" clId="{E77B627B-1F43-41A9-9F24-D4BB31BF6050}" dt="2026-05-28T03:46:43.038" v="237" actId="33524"/>
-        <pc:sldMkLst>
-          <pc:docMk/>
-          <pc:sldMk cId="4257262995" sldId="353"/>
-        </pc:sldMkLst>
-        <pc:spChg chg="mod">
-          <ac:chgData name="Uwe Ricken" userId="f02567aecbed924b" providerId="LiveId" clId="{E77B627B-1F43-41A9-9F24-D4BB31BF6050}" dt="2026-05-28T03:46:43.038" v="237" actId="33524"/>
+        <pc:spChg chg="add mod ord">
+          <ac:chgData name="Uwe Ricken" userId="f02567aecbed924b" providerId="LiveId" clId="{E77B627B-1F43-41A9-9F24-D4BB31BF6050}" dt="2026-09-21T06:59:28.416" v="750" actId="20577"/>
           <ac:spMkLst>
             <pc:docMk/>
-            <pc:sldMk cId="4257262995" sldId="353"/>
-            <ac:spMk id="3" creationId="{11457BA8-2A88-3CC3-2BE1-F8EB62F45485}"/>
+            <pc:sldMk cId="542850919" sldId="431"/>
+            <ac:spMk id="4" creationId="{A5EF6EA5-108D-9347-5C58-BB99DC3C7928}"/>
           </ac:spMkLst>
         </pc:spChg>
-      </pc:sldChg>
-      <pc:sldChg chg="modSp mod">
-        <pc:chgData name="Uwe Ricken" userId="f02567aecbed924b" providerId="LiveId" clId="{E77B627B-1F43-41A9-9F24-D4BB31BF6050}" dt="2026-05-28T03:50:45.964" v="279" actId="113"/>
-        <pc:sldMkLst>
-          <pc:docMk/>
-          <pc:sldMk cId="241859938" sldId="359"/>
-        </pc:sldMkLst>
-        <pc:spChg chg="mod">
-          <ac:chgData name="Uwe Ricken" userId="f02567aecbed924b" providerId="LiveId" clId="{E77B627B-1F43-41A9-9F24-D4BB31BF6050}" dt="2026-05-28T03:50:45.964" v="279" actId="113"/>
+        <pc:spChg chg="add mod ord">
+          <ac:chgData name="Uwe Ricken" userId="f02567aecbed924b" providerId="LiveId" clId="{E77B627B-1F43-41A9-9F24-D4BB31BF6050}" dt="2026-09-21T07:00:57.275" v="752" actId="20577"/>
           <ac:spMkLst>
             <pc:docMk/>
-            <pc:sldMk cId="241859938" sldId="359"/>
-            <ac:spMk id="4" creationId="{1E62805F-7A38-2E10-940D-774E2D786B38}"/>
+            <pc:sldMk cId="542850919" sldId="431"/>
+            <ac:spMk id="5" creationId="{DD464124-FF31-3B4B-1D83-054518A9DD4B}"/>
           </ac:spMkLst>
         </pc:spChg>
-      </pc:sldChg>
-      <pc:sldChg chg="del">
-        <pc:chgData name="Uwe Ricken" userId="f02567aecbed924b" providerId="LiveId" clId="{E77B627B-1F43-41A9-9F24-D4BB31BF6050}" dt="2026-05-27T17:28:27.288" v="15" actId="2696"/>
-        <pc:sldMkLst>
-          <pc:docMk/>
-          <pc:sldMk cId="149338758" sldId="360"/>
-        </pc:sldMkLst>
-      </pc:sldChg>
-      <pc:sldChg chg="del">
-        <pc:chgData name="Uwe Ricken" userId="f02567aecbed924b" providerId="LiveId" clId="{E77B627B-1F43-41A9-9F24-D4BB31BF6050}" dt="2026-05-27T17:28:27.288" v="15" actId="2696"/>
-        <pc:sldMkLst>
-          <pc:docMk/>
-          <pc:sldMk cId="1302213217" sldId="361"/>
-        </pc:sldMkLst>
-      </pc:sldChg>
-      <pc:sldChg chg="del">
-        <pc:chgData name="Uwe Ricken" userId="f02567aecbed924b" providerId="LiveId" clId="{E77B627B-1F43-41A9-9F24-D4BB31BF6050}" dt="2026-05-27T17:28:27.288" v="15" actId="2696"/>
-        <pc:sldMkLst>
-          <pc:docMk/>
-          <pc:sldMk cId="300652429" sldId="362"/>
-        </pc:sldMkLst>
-      </pc:sldChg>
-      <pc:sldChg chg="del">
-        <pc:chgData name="Uwe Ricken" userId="f02567aecbed924b" providerId="LiveId" clId="{E77B627B-1F43-41A9-9F24-D4BB31BF6050}" dt="2026-05-27T17:28:27.288" v="15" actId="2696"/>
-        <pc:sldMkLst>
-          <pc:docMk/>
-          <pc:sldMk cId="2594430820" sldId="363"/>
-        </pc:sldMkLst>
-      </pc:sldChg>
-      <pc:sldChg chg="del">
-        <pc:chgData name="Uwe Ricken" userId="f02567aecbed924b" providerId="LiveId" clId="{E77B627B-1F43-41A9-9F24-D4BB31BF6050}" dt="2026-05-27T17:28:27.288" v="15" actId="2696"/>
-        <pc:sldMkLst>
-          <pc:docMk/>
-          <pc:sldMk cId="3908561497" sldId="364"/>
-        </pc:sldMkLst>
-      </pc:sldChg>
-      <pc:sldChg chg="del">
-        <pc:chgData name="Uwe Ricken" userId="f02567aecbed924b" providerId="LiveId" clId="{E77B627B-1F43-41A9-9F24-D4BB31BF6050}" dt="2026-05-27T17:28:27.288" v="15" actId="2696"/>
-        <pc:sldMkLst>
-          <pc:docMk/>
-          <pc:sldMk cId="3644587536" sldId="365"/>
-        </pc:sldMkLst>
-      </pc:sldChg>
-      <pc:sldChg chg="del">
-        <pc:chgData name="Uwe Ricken" userId="f02567aecbed924b" providerId="LiveId" clId="{E77B627B-1F43-41A9-9F24-D4BB31BF6050}" dt="2026-05-27T17:28:27.288" v="15" actId="2696"/>
-        <pc:sldMkLst>
-          <pc:docMk/>
-          <pc:sldMk cId="4271110123" sldId="366"/>
-        </pc:sldMkLst>
-      </pc:sldChg>
-      <pc:sldChg chg="del">
-        <pc:chgData name="Uwe Ricken" userId="f02567aecbed924b" providerId="LiveId" clId="{E77B627B-1F43-41A9-9F24-D4BB31BF6050}" dt="2026-05-27T17:28:27.288" v="15" actId="2696"/>
-        <pc:sldMkLst>
-          <pc:docMk/>
-          <pc:sldMk cId="1515760421" sldId="367"/>
-        </pc:sldMkLst>
-      </pc:sldChg>
-      <pc:sldChg chg="del">
-        <pc:chgData name="Uwe Ricken" userId="f02567aecbed924b" providerId="LiveId" clId="{E77B627B-1F43-41A9-9F24-D4BB31BF6050}" dt="2026-05-27T17:28:27.288" v="15" actId="2696"/>
-        <pc:sldMkLst>
-          <pc:docMk/>
-          <pc:sldMk cId="3194235068" sldId="368"/>
-        </pc:sldMkLst>
-      </pc:sldChg>
-      <pc:sldChg chg="del">
-        <pc:chgData name="Uwe Ricken" userId="f02567aecbed924b" providerId="LiveId" clId="{E77B627B-1F43-41A9-9F24-D4BB31BF6050}" dt="2026-05-27T17:28:27.288" v="15" actId="2696"/>
-        <pc:sldMkLst>
-          <pc:docMk/>
-          <pc:sldMk cId="3791215495" sldId="369"/>
-        </pc:sldMkLst>
-      </pc:sldChg>
-      <pc:sldChg chg="del">
-        <pc:chgData name="Uwe Ricken" userId="f02567aecbed924b" providerId="LiveId" clId="{E77B627B-1F43-41A9-9F24-D4BB31BF6050}" dt="2026-05-27T17:28:27.288" v="15" actId="2696"/>
-        <pc:sldMkLst>
-          <pc:docMk/>
-          <pc:sldMk cId="845285008" sldId="370"/>
-        </pc:sldMkLst>
-      </pc:sldChg>
-      <pc:sldChg chg="del">
-        <pc:chgData name="Uwe Ricken" userId="f02567aecbed924b" providerId="LiveId" clId="{E77B627B-1F43-41A9-9F24-D4BB31BF6050}" dt="2026-05-27T17:28:27.288" v="15" actId="2696"/>
-        <pc:sldMkLst>
-          <pc:docMk/>
-          <pc:sldMk cId="124401768" sldId="371"/>
-        </pc:sldMkLst>
-      </pc:sldChg>
-      <pc:sldChg chg="del">
-        <pc:chgData name="Uwe Ricken" userId="f02567aecbed924b" providerId="LiveId" clId="{E77B627B-1F43-41A9-9F24-D4BB31BF6050}" dt="2026-05-27T17:28:27.288" v="15" actId="2696"/>
-        <pc:sldMkLst>
-          <pc:docMk/>
-          <pc:sldMk cId="1307778200" sldId="372"/>
-        </pc:sldMkLst>
-      </pc:sldChg>
-      <pc:sldChg chg="del">
-        <pc:chgData name="Uwe Ricken" userId="f02567aecbed924b" providerId="LiveId" clId="{E77B627B-1F43-41A9-9F24-D4BB31BF6050}" dt="2026-05-27T17:28:27.288" v="15" actId="2696"/>
-        <pc:sldMkLst>
-          <pc:docMk/>
-          <pc:sldMk cId="3618388199" sldId="373"/>
-        </pc:sldMkLst>
-      </pc:sldChg>
-      <pc:sldChg chg="del">
-        <pc:chgData name="Uwe Ricken" userId="f02567aecbed924b" providerId="LiveId" clId="{E77B627B-1F43-41A9-9F24-D4BB31BF6050}" dt="2026-05-27T17:28:27.288" v="15" actId="2696"/>
-        <pc:sldMkLst>
-          <pc:docMk/>
-          <pc:sldMk cId="2685282423" sldId="374"/>
-        </pc:sldMkLst>
-      </pc:sldChg>
-      <pc:sldChg chg="del">
-        <pc:chgData name="Uwe Ricken" userId="f02567aecbed924b" providerId="LiveId" clId="{E77B627B-1F43-41A9-9F24-D4BB31BF6050}" dt="2026-05-27T17:28:27.288" v="15" actId="2696"/>
-        <pc:sldMkLst>
-          <pc:docMk/>
-          <pc:sldMk cId="3896721346" sldId="375"/>
-        </pc:sldMkLst>
-      </pc:sldChg>
-      <pc:sldChg chg="del">
-        <pc:chgData name="Uwe Ricken" userId="f02567aecbed924b" providerId="LiveId" clId="{E77B627B-1F43-41A9-9F24-D4BB31BF6050}" dt="2026-05-27T17:28:27.288" v="15" actId="2696"/>
-        <pc:sldMkLst>
-          <pc:docMk/>
-          <pc:sldMk cId="2284248756" sldId="376"/>
-        </pc:sldMkLst>
-      </pc:sldChg>
-      <pc:sldChg chg="del">
-        <pc:chgData name="Uwe Ricken" userId="f02567aecbed924b" providerId="LiveId" clId="{E77B627B-1F43-41A9-9F24-D4BB31BF6050}" dt="2026-05-27T17:28:27.288" v="15" actId="2696"/>
-        <pc:sldMkLst>
-          <pc:docMk/>
-          <pc:sldMk cId="3622975896" sldId="377"/>
-        </pc:sldMkLst>
-      </pc:sldChg>
-      <pc:sldChg chg="del">
-        <pc:chgData name="Uwe Ricken" userId="f02567aecbed924b" providerId="LiveId" clId="{E77B627B-1F43-41A9-9F24-D4BB31BF6050}" dt="2026-05-27T17:28:27.288" v="15" actId="2696"/>
-        <pc:sldMkLst>
-          <pc:docMk/>
-          <pc:sldMk cId="1148597228" sldId="378"/>
-        </pc:sldMkLst>
-      </pc:sldChg>
-      <pc:sldChg chg="del">
-        <pc:chgData name="Uwe Ricken" userId="f02567aecbed924b" providerId="LiveId" clId="{E77B627B-1F43-41A9-9F24-D4BB31BF6050}" dt="2026-05-27T17:28:27.288" v="15" actId="2696"/>
-        <pc:sldMkLst>
-          <pc:docMk/>
-          <pc:sldMk cId="2575939865" sldId="379"/>
-        </pc:sldMkLst>
-      </pc:sldChg>
-      <pc:sldChg chg="del">
-        <pc:chgData name="Uwe Ricken" userId="f02567aecbed924b" providerId="LiveId" clId="{E77B627B-1F43-41A9-9F24-D4BB31BF6050}" dt="2026-05-27T17:28:27.288" v="15" actId="2696"/>
-        <pc:sldMkLst>
-          <pc:docMk/>
-          <pc:sldMk cId="1156099314" sldId="380"/>
-        </pc:sldMkLst>
-      </pc:sldChg>
-      <pc:sldChg chg="del">
-        <pc:chgData name="Uwe Ricken" userId="f02567aecbed924b" providerId="LiveId" clId="{E77B627B-1F43-41A9-9F24-D4BB31BF6050}" dt="2026-05-27T17:28:27.288" v="15" actId="2696"/>
-        <pc:sldMkLst>
-          <pc:docMk/>
-          <pc:sldMk cId="367171445" sldId="381"/>
-        </pc:sldMkLst>
-      </pc:sldChg>
-      <pc:sldChg chg="del">
-        <pc:chgData name="Uwe Ricken" userId="f02567aecbed924b" providerId="LiveId" clId="{E77B627B-1F43-41A9-9F24-D4BB31BF6050}" dt="2026-05-27T17:28:27.288" v="15" actId="2696"/>
-        <pc:sldMkLst>
-          <pc:docMk/>
-          <pc:sldMk cId="2003074078" sldId="382"/>
-        </pc:sldMkLst>
-      </pc:sldChg>
-      <pc:sldChg chg="del">
-        <pc:chgData name="Uwe Ricken" userId="f02567aecbed924b" providerId="LiveId" clId="{E77B627B-1F43-41A9-9F24-D4BB31BF6050}" dt="2026-05-27T17:28:27.288" v="15" actId="2696"/>
-        <pc:sldMkLst>
-          <pc:docMk/>
-          <pc:sldMk cId="3799856774" sldId="383"/>
-        </pc:sldMkLst>
-      </pc:sldChg>
-      <pc:sldChg chg="del">
-        <pc:chgData name="Uwe Ricken" userId="f02567aecbed924b" providerId="LiveId" clId="{E77B627B-1F43-41A9-9F24-D4BB31BF6050}" dt="2026-05-27T17:28:27.288" v="15" actId="2696"/>
-        <pc:sldMkLst>
-          <pc:docMk/>
-          <pc:sldMk cId="367371729" sldId="384"/>
-        </pc:sldMkLst>
-      </pc:sldChg>
-      <pc:sldChg chg="del">
-        <pc:chgData name="Uwe Ricken" userId="f02567aecbed924b" providerId="LiveId" clId="{E77B627B-1F43-41A9-9F24-D4BB31BF6050}" dt="2026-05-27T17:28:27.288" v="15" actId="2696"/>
-        <pc:sldMkLst>
-          <pc:docMk/>
-          <pc:sldMk cId="784247027" sldId="385"/>
-        </pc:sldMkLst>
-      </pc:sldChg>
-      <pc:sldChg chg="del">
-        <pc:chgData name="Uwe Ricken" userId="f02567aecbed924b" providerId="LiveId" clId="{E77B627B-1F43-41A9-9F24-D4BB31BF6050}" dt="2026-05-27T17:28:27.288" v="15" actId="2696"/>
-        <pc:sldMkLst>
-          <pc:docMk/>
-          <pc:sldMk cId="3574118892" sldId="386"/>
-        </pc:sldMkLst>
-      </pc:sldChg>
-      <pc:sldChg chg="modSp mod">
-        <pc:chgData name="Uwe Ricken" userId="f02567aecbed924b" providerId="LiveId" clId="{E77B627B-1F43-41A9-9F24-D4BB31BF6050}" dt="2026-05-27T17:38:15.654" v="38" actId="20577"/>
-        <pc:sldMkLst>
-          <pc:docMk/>
-          <pc:sldMk cId="197504835" sldId="387"/>
-        </pc:sldMkLst>
-        <pc:spChg chg="mod">
-          <ac:chgData name="Uwe Ricken" userId="f02567aecbed924b" providerId="LiveId" clId="{E77B627B-1F43-41A9-9F24-D4BB31BF6050}" dt="2026-05-27T17:38:02.722" v="22" actId="20577"/>
-          <ac:spMkLst>
-            <pc:docMk/>
-            <pc:sldMk cId="197504835" sldId="387"/>
-            <ac:spMk id="23" creationId="{120FC17E-37AC-0FB3-2667-B12E40E4091D}"/>
-          </ac:spMkLst>
-        </pc:spChg>
-        <pc:spChg chg="mod">
-          <ac:chgData name="Uwe Ricken" userId="f02567aecbed924b" providerId="LiveId" clId="{E77B627B-1F43-41A9-9F24-D4BB31BF6050}" dt="2026-05-27T17:38:12.240" v="31" actId="20577"/>
-          <ac:spMkLst>
-            <pc:docMk/>
-            <pc:sldMk cId="197504835" sldId="387"/>
-            <ac:spMk id="24" creationId="{27BA4003-7B39-2668-1289-D3803DDD0D1F}"/>
-          </ac:spMkLst>
-        </pc:spChg>
-        <pc:spChg chg="mod">
-          <ac:chgData name="Uwe Ricken" userId="f02567aecbed924b" providerId="LiveId" clId="{E77B627B-1F43-41A9-9F24-D4BB31BF6050}" dt="2026-05-27T17:38:15.654" v="38" actId="20577"/>
-          <ac:spMkLst>
-            <pc:docMk/>
-            <pc:sldMk cId="197504835" sldId="387"/>
-            <ac:spMk id="25" creationId="{28B5EBFC-076E-B1E9-A1D0-BAD4AC891F1D}"/>
-          </ac:spMkLst>
-        </pc:spChg>
-      </pc:sldChg>
-      <pc:sldChg chg="modSp mod">
-        <pc:chgData name="Uwe Ricken" userId="f02567aecbed924b" providerId="LiveId" clId="{E77B627B-1F43-41A9-9F24-D4BB31BF6050}" dt="2026-05-28T03:45:54.997" v="234" actId="113"/>
-        <pc:sldMkLst>
-          <pc:docMk/>
-          <pc:sldMk cId="920153184" sldId="390"/>
-        </pc:sldMkLst>
-        <pc:spChg chg="mod">
-          <ac:chgData name="Uwe Ricken" userId="f02567aecbed924b" providerId="LiveId" clId="{E77B627B-1F43-41A9-9F24-D4BB31BF6050}" dt="2026-05-28T03:45:54.997" v="234" actId="113"/>
-          <ac:spMkLst>
-            <pc:docMk/>
-            <pc:sldMk cId="920153184" sldId="390"/>
-            <ac:spMk id="3" creationId="{C03F04A0-E173-0D1F-03D7-387856EB6250}"/>
-          </ac:spMkLst>
-        </pc:spChg>
-      </pc:sldChg>
-      <pc:sldChg chg="addSp delSp modSp new mod modAnim">
-        <pc:chgData name="Uwe Ricken" userId="f02567aecbed924b" providerId="LiveId" clId="{E77B627B-1F43-41A9-9F24-D4BB31BF6050}" dt="2026-05-27T17:48:24.688" v="225"/>
-        <pc:sldMkLst>
-          <pc:docMk/>
-          <pc:sldMk cId="571783422" sldId="391"/>
-        </pc:sldMkLst>
-        <pc:spChg chg="mod">
-          <ac:chgData name="Uwe Ricken" userId="f02567aecbed924b" providerId="LiveId" clId="{E77B627B-1F43-41A9-9F24-D4BB31BF6050}" dt="2026-05-27T17:41:08.932" v="76" actId="20577"/>
-          <ac:spMkLst>
-            <pc:docMk/>
-            <pc:sldMk cId="571783422" sldId="391"/>
-            <ac:spMk id="2" creationId="{E8859812-683F-5BCC-2F2E-B395BCC97FAA}"/>
-          </ac:spMkLst>
-        </pc:spChg>
-        <pc:spChg chg="add mod">
-          <ac:chgData name="Uwe Ricken" userId="f02567aecbed924b" providerId="LiveId" clId="{E77B627B-1F43-41A9-9F24-D4BB31BF6050}" dt="2026-05-27T17:42:03.311" v="79" actId="14100"/>
-          <ac:spMkLst>
-            <pc:docMk/>
-            <pc:sldMk cId="571783422" sldId="391"/>
-            <ac:spMk id="3" creationId="{645989F9-5836-EBB4-1F0B-CBC1050166E3}"/>
-          </ac:spMkLst>
-        </pc:spChg>
-        <pc:spChg chg="add mod">
-          <ac:chgData name="Uwe Ricken" userId="f02567aecbed924b" providerId="LiveId" clId="{E77B627B-1F43-41A9-9F24-D4BB31BF6050}" dt="2026-05-27T17:47:03.616" v="197" actId="20577"/>
-          <ac:spMkLst>
-            <pc:docMk/>
-            <pc:sldMk cId="571783422" sldId="391"/>
-            <ac:spMk id="4" creationId="{49687EB7-54C8-E618-A0E8-E90D94AE9131}"/>
-          </ac:spMkLst>
-        </pc:spChg>
-        <pc:spChg chg="add mod">
-          <ac:chgData name="Uwe Ricken" userId="f02567aecbed924b" providerId="LiveId" clId="{E77B627B-1F43-41A9-9F24-D4BB31BF6050}" dt="2026-05-27T17:47:34.141" v="219" actId="20577"/>
-          <ac:spMkLst>
-            <pc:docMk/>
-            <pc:sldMk cId="571783422" sldId="391"/>
-            <ac:spMk id="5" creationId="{A087EC59-8F0C-C9DF-6FD3-5AA54FC0C56C}"/>
-          </ac:spMkLst>
-        </pc:spChg>
-        <pc:spChg chg="add mod">
-          <ac:chgData name="Uwe Ricken" userId="f02567aecbed924b" providerId="LiveId" clId="{E77B627B-1F43-41A9-9F24-D4BB31BF6050}" dt="2026-05-27T17:47:28.026" v="215" actId="20577"/>
-          <ac:spMkLst>
-            <pc:docMk/>
-            <pc:sldMk cId="571783422" sldId="391"/>
-            <ac:spMk id="6" creationId="{89B74418-70F7-76FC-2D20-624F1A86452B}"/>
-          </ac:spMkLst>
-        </pc:spChg>
-        <pc:spChg chg="add mod">
-          <ac:chgData name="Uwe Ricken" userId="f02567aecbed924b" providerId="LiveId" clId="{E77B627B-1F43-41A9-9F24-D4BB31BF6050}" dt="2026-05-27T17:47:11.659" v="202" actId="14100"/>
-          <ac:spMkLst>
-            <pc:docMk/>
-            <pc:sldMk cId="571783422" sldId="391"/>
-            <ac:spMk id="7" creationId="{4A87539F-0BB8-EF25-0D5C-54073CB9334F}"/>
-          </ac:spMkLst>
-        </pc:spChg>
-        <pc:spChg chg="add mod">
-          <ac:chgData name="Uwe Ricken" userId="f02567aecbed924b" providerId="LiveId" clId="{E77B627B-1F43-41A9-9F24-D4BB31BF6050}" dt="2026-05-27T17:47:22.224" v="211" actId="14100"/>
-          <ac:spMkLst>
-            <pc:docMk/>
-            <pc:sldMk cId="571783422" sldId="391"/>
-            <ac:spMk id="8" creationId="{2D5D60E5-E7D4-BB0A-4C7B-93F9F77C39DF}"/>
-          </ac:spMkLst>
-        </pc:spChg>
-        <pc:cxnChg chg="add">
-          <ac:chgData name="Uwe Ricken" userId="f02567aecbed924b" providerId="LiveId" clId="{E77B627B-1F43-41A9-9F24-D4BB31BF6050}" dt="2026-05-27T17:45:08.566" v="177" actId="11529"/>
-          <ac:cxnSpMkLst>
-            <pc:docMk/>
-            <pc:sldMk cId="571783422" sldId="391"/>
-            <ac:cxnSpMk id="10" creationId="{00144B79-5D66-0891-2FF3-6906DDC2C352}"/>
-          </ac:cxnSpMkLst>
-        </pc:cxnChg>
-        <pc:cxnChg chg="add mod">
-          <ac:chgData name="Uwe Ricken" userId="f02567aecbed924b" providerId="LiveId" clId="{E77B627B-1F43-41A9-9F24-D4BB31BF6050}" dt="2026-05-27T17:47:11.659" v="202" actId="14100"/>
-          <ac:cxnSpMkLst>
-            <pc:docMk/>
-            <pc:sldMk cId="571783422" sldId="391"/>
-            <ac:cxnSpMk id="12" creationId="{57060656-2FAF-15D9-2FFF-5B10CECE7636}"/>
-          </ac:cxnSpMkLst>
-        </pc:cxnChg>
-        <pc:cxnChg chg="add mod">
-          <ac:chgData name="Uwe Ricken" userId="f02567aecbed924b" providerId="LiveId" clId="{E77B627B-1F43-41A9-9F24-D4BB31BF6050}" dt="2026-05-27T17:47:22.224" v="211" actId="14100"/>
-          <ac:cxnSpMkLst>
-            <pc:docMk/>
-            <pc:sldMk cId="571783422" sldId="391"/>
-            <ac:cxnSpMk id="14" creationId="{75F2C748-F3EA-7F0F-B27E-F50AD7720FCB}"/>
-          </ac:cxnSpMkLst>
-        </pc:cxnChg>
-        <pc:cxnChg chg="add del mod">
-          <ac:chgData name="Uwe Ricken" userId="f02567aecbed924b" providerId="LiveId" clId="{E77B627B-1F43-41A9-9F24-D4BB31BF6050}" dt="2026-05-27T17:45:40.597" v="181" actId="478"/>
-          <ac:cxnSpMkLst>
-            <pc:docMk/>
-            <pc:sldMk cId="571783422" sldId="391"/>
-            <ac:cxnSpMk id="16" creationId="{6C9EE262-077B-5BCE-450B-E8EF7D4996E9}"/>
-          </ac:cxnSpMkLst>
-        </pc:cxnChg>
-        <pc:cxnChg chg="add mod">
-          <ac:chgData name="Uwe Ricken" userId="f02567aecbed924b" providerId="LiveId" clId="{E77B627B-1F43-41A9-9F24-D4BB31BF6050}" dt="2026-05-27T17:47:22.224" v="211" actId="14100"/>
-          <ac:cxnSpMkLst>
-            <pc:docMk/>
-            <pc:sldMk cId="571783422" sldId="391"/>
-            <ac:cxnSpMk id="18" creationId="{F9B6A10C-6392-5C62-57F6-6232CD5702B2}"/>
-          </ac:cxnSpMkLst>
-        </pc:cxnChg>
-        <pc:cxnChg chg="add">
-          <ac:chgData name="Uwe Ricken" userId="f02567aecbed924b" providerId="LiveId" clId="{E77B627B-1F43-41A9-9F24-D4BB31BF6050}" dt="2026-05-27T17:46:25.125" v="189" actId="11529"/>
-          <ac:cxnSpMkLst>
-            <pc:docMk/>
-            <pc:sldMk cId="571783422" sldId="391"/>
-            <ac:cxnSpMk id="24" creationId="{0C277BDF-9A76-F357-E73A-85C42E5BCF8D}"/>
-          </ac:cxnSpMkLst>
-        </pc:cxnChg>
-      </pc:sldChg>
-      <pc:sldChg chg="modSp add mod">
-        <pc:chgData name="Uwe Ricken" userId="f02567aecbed924b" providerId="LiveId" clId="{E77B627B-1F43-41A9-9F24-D4BB31BF6050}" dt="2026-05-28T03:50:27.925" v="278" actId="20577"/>
-        <pc:sldMkLst>
-          <pc:docMk/>
-          <pc:sldMk cId="2669480126" sldId="392"/>
-        </pc:sldMkLst>
-        <pc:spChg chg="mod">
-          <ac:chgData name="Uwe Ricken" userId="f02567aecbed924b" providerId="LiveId" clId="{E77B627B-1F43-41A9-9F24-D4BB31BF6050}" dt="2026-05-28T03:47:52.205" v="239" actId="20577"/>
-          <ac:spMkLst>
-            <pc:docMk/>
-            <pc:sldMk cId="2669480126" sldId="392"/>
-            <ac:spMk id="2" creationId="{4DA7B31B-51CB-B477-B2E2-8EB46ACCE5EF}"/>
-          </ac:spMkLst>
-        </pc:spChg>
-        <pc:spChg chg="mod">
-          <ac:chgData name="Uwe Ricken" userId="f02567aecbed924b" providerId="LiveId" clId="{E77B627B-1F43-41A9-9F24-D4BB31BF6050}" dt="2026-05-28T03:50:27.925" v="278" actId="20577"/>
-          <ac:spMkLst>
-            <pc:docMk/>
-            <pc:sldMk cId="2669480126" sldId="392"/>
-            <ac:spMk id="3" creationId="{ED40C9EC-951A-8100-AD1B-EB8F8E41094F}"/>
-          </ac:spMkLst>
-        </pc:spChg>
-      </pc:sldChg>
-      <pc:sldChg chg="modSp add mod">
-        <pc:chgData name="Uwe Ricken" userId="f02567aecbed924b" providerId="LiveId" clId="{E77B627B-1F43-41A9-9F24-D4BB31BF6050}" dt="2026-05-28T03:55:36.066" v="715" actId="33524"/>
-        <pc:sldMkLst>
-          <pc:docMk/>
-          <pc:sldMk cId="71853060" sldId="393"/>
-        </pc:sldMkLst>
-        <pc:spChg chg="mod">
-          <ac:chgData name="Uwe Ricken" userId="f02567aecbed924b" providerId="LiveId" clId="{E77B627B-1F43-41A9-9F24-D4BB31BF6050}" dt="2026-05-28T03:51:21.999" v="281" actId="20577"/>
-          <ac:spMkLst>
-            <pc:docMk/>
-            <pc:sldMk cId="71853060" sldId="393"/>
-            <ac:spMk id="2" creationId="{CC4229B2-210D-3A1A-65D3-BD6640016A6D}"/>
-          </ac:spMkLst>
-        </pc:spChg>
-        <pc:spChg chg="mod">
-          <ac:chgData name="Uwe Ricken" userId="f02567aecbed924b" providerId="LiveId" clId="{E77B627B-1F43-41A9-9F24-D4BB31BF6050}" dt="2026-05-28T03:55:36.066" v="715" actId="33524"/>
-          <ac:spMkLst>
-            <pc:docMk/>
-            <pc:sldMk cId="71853060" sldId="393"/>
-            <ac:spMk id="4" creationId="{29E9247A-0494-7C3B-171F-710B40AFE029}"/>
-          </ac:spMkLst>
-        </pc:spChg>
-      </pc:sldChg>
-      <pc:sldChg chg="add">
-        <pc:chgData name="Uwe Ricken" userId="f02567aecbed924b" providerId="LiveId" clId="{E77B627B-1F43-41A9-9F24-D4BB31BF6050}" dt="2026-05-28T03:56:04.672" v="716"/>
-        <pc:sldMkLst>
-          <pc:docMk/>
-          <pc:sldMk cId="1555885432" sldId="430"/>
-        </pc:sldMkLst>
       </pc:sldChg>
     </pc:docChg>
   </pc:docChgLst>
@@ -774,7 +309,7 @@
           <a:p>
             <a:fld id="{54B63C78-F46A-42B2-BCDE-B4D920D39058}" type="datetimeFigureOut">
               <a:rPr lang="de-DE" smtClean="0"/>
-              <a:t>28.05.2026</a:t>
+              <a:t>21.09.2026</a:t>
             </a:fld>
             <a:endParaRPr lang="de-DE"/>
           </a:p>
@@ -1069,6 +604,13 @@
           </p:nvPr>
         </p:nvSpPr>
         <p:spPr/>
+        <p:txBody>
+          <a:bodyPr/>
+          <a:lstStyle/>
+          <a:p>
+            <a:endParaRPr lang="en-US"/>
+          </a:p>
+        </p:txBody>
       </p:sp>
       <p:sp>
         <p:nvSpPr>
@@ -1116,90 +658,6 @@
     <p:extLst>
       <p:ext uri="{BB962C8B-B14F-4D97-AF65-F5344CB8AC3E}">
         <p14:creationId xmlns:p14="http://schemas.microsoft.com/office/powerpoint/2010/main" val="3534165857"/>
-      </p:ext>
-    </p:extLst>
-  </p:cSld>
-  <p:clrMapOvr>
-    <a:masterClrMapping/>
-  </p:clrMapOvr>
-</p:notes>
-</file>
-
-<file path=ppt/notesSlides/notesSlide2.xml><?xml version="1.0" encoding="utf-8"?>
-<p:notes xmlns:a="http://schemas.openxmlformats.org/drawingml/2006/main" xmlns:r="http://schemas.openxmlformats.org/officeDocument/2006/relationships" xmlns:p="http://schemas.openxmlformats.org/presentationml/2006/main">
-  <p:cSld>
-    <p:spTree>
-      <p:nvGrpSpPr>
-        <p:cNvPr id="1" name=""/>
-        <p:cNvGrpSpPr/>
-        <p:nvPr/>
-      </p:nvGrpSpPr>
-      <p:grpSpPr>
-        <a:xfrm>
-          <a:off x="0" y="0"/>
-          <a:ext cx="0" cy="0"/>
-          <a:chOff x="0" y="0"/>
-          <a:chExt cx="0" cy="0"/>
-        </a:xfrm>
-      </p:grpSpPr>
-      <p:sp>
-        <p:nvSpPr>
-          <p:cNvPr id="2" name="Zástupný symbol pro obrázek snímku 1"/>
-          <p:cNvSpPr>
-            <a:spLocks noGrp="1" noRot="1" noChangeAspect="1"/>
-          </p:cNvSpPr>
-          <p:nvPr>
-            <p:ph type="sldImg"/>
-          </p:nvPr>
-        </p:nvSpPr>
-        <p:spPr/>
-      </p:sp>
-      <p:sp>
-        <p:nvSpPr>
-          <p:cNvPr id="3" name="Zástupný symbol pro poznámky 2"/>
-          <p:cNvSpPr>
-            <a:spLocks noGrp="1"/>
-          </p:cNvSpPr>
-          <p:nvPr>
-            <p:ph type="body" idx="1"/>
-          </p:nvPr>
-        </p:nvSpPr>
-        <p:spPr/>
-        <p:txBody>
-          <a:bodyPr/>
-          <a:lstStyle/>
-          <a:p>
-            <a:endParaRPr lang="cs-CZ" dirty="0"/>
-          </a:p>
-        </p:txBody>
-      </p:sp>
-      <p:sp>
-        <p:nvSpPr>
-          <p:cNvPr id="4" name="Zástupný symbol pro číslo snímku 3"/>
-          <p:cNvSpPr>
-            <a:spLocks noGrp="1"/>
-          </p:cNvSpPr>
-          <p:nvPr>
-            <p:ph type="sldNum" sz="quarter" idx="5"/>
-          </p:nvPr>
-        </p:nvSpPr>
-        <p:spPr/>
-        <p:txBody>
-          <a:bodyPr/>
-          <a:lstStyle/>
-          <a:p>
-            <a:fld id="{C0371467-0A66-4746-9955-D9300FEA8EA5}" type="slidenum">
-              <a:rPr lang="cs-CZ" smtClean="0"/>
-              <a:t>2</a:t>
-            </a:fld>
-            <a:endParaRPr lang="cs-CZ"/>
-          </a:p>
-        </p:txBody>
-      </p:sp>
-    </p:spTree>
-    <p:extLst>
-      <p:ext uri="{BB962C8B-B14F-4D97-AF65-F5344CB8AC3E}">
-        <p14:creationId xmlns:p14="http://schemas.microsoft.com/office/powerpoint/2010/main" val="4221108694"/>
       </p:ext>
     </p:extLst>
   </p:cSld>
@@ -4917,13 +4375,10 @@
           <a:p>
             <a:pPr algn="ctr"/>
             <a:r>
-              <a:rPr lang="de-DE" b="1" dirty="0" err="1">
-                <a:solidFill>
-                  <a:srgbClr val="165364"/>
-                </a:solidFill>
-                <a:latin typeface="verdana" panose="020B0604030504040204" pitchFamily="34" charset="0"/>
+              <a:rPr lang="en-US" b="1" dirty="0">
+                <a:hlinkClick r:id="rId3"/>
               </a:rPr>
-              <a:t>tba</a:t>
+              <a:t>https://github.com/db-berater/speedup-your-sql-code</a:t>
             </a:r>
             <a:endParaRPr lang="de-DE" b="1" dirty="0"/>
           </a:p>
@@ -6346,7 +5801,7 @@
             <a:pPr lvl="1"/>
             <a:r>
               <a:rPr lang="en-US" dirty="0"/>
-              <a:t>A job engine produces 24/7 for ~16.000.000 customers on a daily basis a class-type calculation. Since lots of customers must be recalculated every day, the job engine is working with 20 simultaneous processes.</a:t>
+              <a:t>A job engine produces 24/7 for ~1.600.000 customers daily a class-type calculation. Since lots of customers must be recalculated every day, the job engine is working with 20 simultaneous processes.</a:t>
             </a:r>
           </a:p>
           <a:p>
@@ -6354,6 +5809,13 @@
             <a:r>
               <a:rPr lang="en-US" dirty="0"/>
               <a:t>The developers are using a User Defined Function for the calculation of the class type!</a:t>
+            </a:r>
+          </a:p>
+          <a:p>
+            <a:pPr lvl="1"/>
+            <a:r>
+              <a:rPr lang="en-US" dirty="0"/>
+              <a:t>If there are no numbers for the given year, the UDF is using the previous year and reduce the classification by one step (e.g. an “A” in the previous year turns into a “B” for the actual year).</a:t>
             </a:r>
           </a:p>
           <a:p>
@@ -6735,13 +6197,7 @@
   <p:cSld>
     <p:spTree>
       <p:nvGrpSpPr>
-        <p:cNvPr id="1" name="">
-          <a:extLst>
-            <a:ext uri="{FF2B5EF4-FFF2-40B4-BE49-F238E27FC236}">
-              <a16:creationId xmlns:a16="http://schemas.microsoft.com/office/drawing/2014/main" id="{CE28DF8F-3704-1C69-2733-716B33A9A265}"/>
-            </a:ext>
-          </a:extLst>
-        </p:cNvPr>
+        <p:cNvPr id="1" name=""/>
         <p:cNvGrpSpPr/>
         <p:nvPr/>
       </p:nvGrpSpPr>
@@ -6755,663 +6211,436 @@
       </p:grpSpPr>
       <p:sp>
         <p:nvSpPr>
-          <p:cNvPr id="2" name="TextovéPole 1">
+          <p:cNvPr id="4" name="Titel 3"/>
+          <p:cNvSpPr>
+            <a:spLocks noGrp="1"/>
+          </p:cNvSpPr>
+          <p:nvPr>
+            <p:ph type="title"/>
+          </p:nvPr>
+        </p:nvSpPr>
+        <p:spPr/>
+        <p:txBody>
+          <a:bodyPr/>
+          <a:lstStyle/>
+          <a:p>
+            <a:r>
+              <a:rPr lang="de-DE" dirty="0"/>
+              <a:t>Uwe Ricken</a:t>
+            </a:r>
+            <a:br>
+              <a:rPr lang="de-DE" dirty="0"/>
+            </a:br>
+            <a:r>
+              <a:rPr lang="de-DE" sz="2400" dirty="0"/>
+              <a:t>db Berater GmbH</a:t>
+            </a:r>
+          </a:p>
+        </p:txBody>
+      </p:sp>
+      <p:sp>
+        <p:nvSpPr>
+          <p:cNvPr id="2" name="Inhaltsplatzhalter 1"/>
+          <p:cNvSpPr>
+            <a:spLocks noGrp="1"/>
+          </p:cNvSpPr>
+          <p:nvPr>
+            <p:ph sz="half" idx="1"/>
+          </p:nvPr>
+        </p:nvSpPr>
+        <p:spPr>
+          <a:prstGeom prst="rect">
+            <a:avLst/>
+          </a:prstGeom>
+        </p:spPr>
+        <p:txBody>
+          <a:bodyPr>
+            <a:normAutofit/>
+          </a:bodyPr>
+          <a:lstStyle/>
+          <a:p>
+            <a:pPr marL="457166" lvl="1" indent="0">
+              <a:buNone/>
+            </a:pPr>
+            <a:r>
+              <a:rPr lang="en-US" sz="1400" dirty="0"/>
+              <a:t>I am working with IT-systems since early 1990's and with the main focus on </a:t>
+            </a:r>
+            <a:r>
+              <a:rPr lang="en-US" sz="1400" b="1" i="1" dirty="0">
+                <a:solidFill>
+                  <a:schemeClr val="accent5"/>
+                </a:solidFill>
+              </a:rPr>
+              <a:t>Microsoft SQL Server </a:t>
+            </a:r>
+            <a:r>
+              <a:rPr lang="en-US" sz="1400" dirty="0"/>
+              <a:t>since version 6.0. I started with development of database applications in 1998 with a professional CRM-System based on Microsoft products (Microsoft Office and </a:t>
+            </a:r>
+            <a:r>
+              <a:rPr lang="en-US" sz="1400" b="1" i="1" dirty="0">
+                <a:solidFill>
+                  <a:schemeClr val="accent5"/>
+                </a:solidFill>
+              </a:rPr>
+              <a:t>Microsoft SQL Server</a:t>
+            </a:r>
+            <a:r>
+              <a:rPr lang="en-US" sz="1400" dirty="0"/>
+              <a:t>).</a:t>
+            </a:r>
+          </a:p>
+          <a:p>
+            <a:pPr marL="457166" lvl="1" indent="0">
+              <a:buNone/>
+            </a:pPr>
+            <a:br>
+              <a:rPr lang="en-US" sz="1400" dirty="0"/>
+            </a:br>
+            <a:r>
+              <a:rPr lang="en-US" sz="1400" dirty="0"/>
+              <a:t>Since 2008 I'm focused exclusively on </a:t>
+            </a:r>
+            <a:r>
+              <a:rPr lang="en-US" sz="1400" b="1" i="1" dirty="0">
+                <a:solidFill>
+                  <a:schemeClr val="accent5"/>
+                </a:solidFill>
+              </a:rPr>
+              <a:t>Microsoft SQL Server</a:t>
+            </a:r>
+            <a:r>
+              <a:rPr lang="en-US" sz="1400" dirty="0"/>
+              <a:t> and I was working in 3rd level support teams for enterprise companies, banks and insurances.</a:t>
+            </a:r>
+          </a:p>
+          <a:p>
+            <a:pPr marL="457166" lvl="1" indent="0">
+              <a:buNone/>
+            </a:pPr>
+            <a:endParaRPr lang="en-US" sz="1400" dirty="0"/>
+          </a:p>
+          <a:p>
+            <a:pPr marL="457166" lvl="1" indent="0">
+              <a:buNone/>
+            </a:pPr>
+            <a:r>
+              <a:rPr lang="en-US" sz="1400" dirty="0"/>
+              <a:t>Since May 2013 I'm a </a:t>
+            </a:r>
+            <a:r>
+              <a:rPr lang="en-US" sz="1400" b="1" dirty="0">
+                <a:solidFill>
+                  <a:srgbClr val="FF0000"/>
+                </a:solidFill>
+              </a:rPr>
+              <a:t>Microsoft Certified Master: SQL Server 2008 </a:t>
+            </a:r>
+            <a:r>
+              <a:rPr lang="en-US" sz="1400" dirty="0"/>
+              <a:t>which was an amazing way into the depth of </a:t>
+            </a:r>
+            <a:r>
+              <a:rPr lang="en-US" sz="1400" b="1" i="1" dirty="0">
+                <a:solidFill>
+                  <a:schemeClr val="accent5"/>
+                </a:solidFill>
+              </a:rPr>
+              <a:t>Microsoft SQL Server</a:t>
+            </a:r>
+            <a:r>
+              <a:rPr lang="en-US" sz="1400" dirty="0"/>
+              <a:t>.</a:t>
+            </a:r>
+          </a:p>
+          <a:p>
+            <a:pPr marL="457166" lvl="1" indent="0">
+              <a:buNone/>
+            </a:pPr>
+            <a:endParaRPr lang="en-US" sz="1400" dirty="0"/>
+          </a:p>
+          <a:p>
+            <a:pPr marL="457166" lvl="1" indent="0">
+              <a:buNone/>
+            </a:pPr>
+            <a:r>
+              <a:rPr lang="en-US" sz="1400" dirty="0"/>
+              <a:t>In July 2013 I have been awarded with the MVP Award for </a:t>
+            </a:r>
+            <a:r>
+              <a:rPr lang="en-US" sz="1400" b="1" i="1" dirty="0">
+                <a:solidFill>
+                  <a:schemeClr val="accent5"/>
+                </a:solidFill>
+              </a:rPr>
+              <a:t>Microsoft SQL Server</a:t>
+            </a:r>
+            <a:r>
+              <a:rPr lang="en-US" sz="1400" dirty="0"/>
+              <a:t>.</a:t>
+            </a:r>
+            <a:endParaRPr lang="de-DE" sz="1400" dirty="0"/>
+          </a:p>
+        </p:txBody>
+      </p:sp>
+      <p:sp>
+        <p:nvSpPr>
+          <p:cNvPr id="6" name="Textplatzhalter 5"/>
+          <p:cNvSpPr>
+            <a:spLocks noGrp="1"/>
+          </p:cNvSpPr>
+          <p:nvPr>
+            <p:ph sz="half" idx="2"/>
+          </p:nvPr>
+        </p:nvSpPr>
+        <p:spPr>
+          <a:prstGeom prst="rect">
+            <a:avLst/>
+          </a:prstGeom>
+        </p:spPr>
+        <p:txBody>
+          <a:bodyPr>
+            <a:noAutofit/>
+          </a:bodyPr>
+          <a:lstStyle/>
+          <a:p>
+            <a:pPr marL="0" indent="0">
+              <a:buNone/>
+              <a:tabLst>
+                <a:tab pos="903243" algn="l"/>
+              </a:tabLst>
+            </a:pPr>
+            <a:r>
+              <a:rPr lang="de-DE" sz="1400" b="1" dirty="0" err="1"/>
+              <a:t>www</a:t>
+            </a:r>
+            <a:r>
+              <a:rPr lang="de-DE" sz="1400" dirty="0"/>
+              <a:t>:	</a:t>
+            </a:r>
+            <a:r>
+              <a:rPr lang="de-DE" sz="1400" dirty="0">
+                <a:hlinkClick r:id="rId2"/>
+              </a:rPr>
+              <a:t>http://www.db-berater.de</a:t>
+            </a:r>
+            <a:endParaRPr lang="de-DE" sz="1400" dirty="0"/>
+          </a:p>
+          <a:p>
+            <a:pPr marL="0" indent="0">
+              <a:buNone/>
+              <a:tabLst>
+                <a:tab pos="903243" algn="l"/>
+              </a:tabLst>
+            </a:pPr>
+            <a:r>
+              <a:rPr lang="de-DE" sz="1400" b="1" dirty="0"/>
+              <a:t>email</a:t>
+            </a:r>
+            <a:r>
+              <a:rPr lang="de-DE" sz="1400" dirty="0"/>
+              <a:t>:	</a:t>
+            </a:r>
+            <a:r>
+              <a:rPr lang="de-DE" sz="1400" dirty="0">
+                <a:hlinkClick r:id="rId3"/>
+              </a:rPr>
+              <a:t>uwe.ricken@db-berater.de</a:t>
+            </a:r>
+            <a:endParaRPr lang="de-DE" sz="1400" dirty="0"/>
+          </a:p>
+          <a:p>
+            <a:pPr marL="0" indent="0">
+              <a:buNone/>
+              <a:tabLst>
+                <a:tab pos="903243" algn="l"/>
+              </a:tabLst>
+            </a:pPr>
+            <a:r>
+              <a:rPr lang="de-DE" sz="1400" b="1" dirty="0" err="1"/>
+              <a:t>blog</a:t>
+            </a:r>
+            <a:r>
+              <a:rPr lang="de-DE" sz="1400" dirty="0"/>
+              <a:t>:	</a:t>
+            </a:r>
+            <a:r>
+              <a:rPr lang="de-DE" sz="1400" dirty="0">
+                <a:hlinkClick r:id="rId4"/>
+              </a:rPr>
+              <a:t>http://www.sqlmaster.de</a:t>
+            </a:r>
+            <a:endParaRPr lang="de-DE" sz="1400" dirty="0"/>
+          </a:p>
+          <a:p>
+            <a:pPr marL="0" indent="0">
+              <a:buNone/>
+              <a:tabLst>
+                <a:tab pos="903243" algn="l"/>
+              </a:tabLst>
+            </a:pPr>
+            <a:r>
+              <a:rPr lang="de-DE" sz="1400" dirty="0"/>
+              <a:t>LinkedIn:	</a:t>
+            </a:r>
+            <a:r>
+              <a:rPr lang="de-DE" sz="1400" dirty="0">
+                <a:hlinkClick r:id="rId5"/>
+              </a:rPr>
+              <a:t>https://www.linkedin.com/in/uwericken</a:t>
+            </a:r>
+            <a:endParaRPr lang="de-DE" sz="1400" dirty="0"/>
+          </a:p>
+          <a:p>
+            <a:pPr marL="0" indent="0">
+              <a:buNone/>
+              <a:tabLst>
+                <a:tab pos="903243" algn="l"/>
+              </a:tabLst>
+            </a:pPr>
+            <a:endParaRPr lang="de-DE" sz="1400" dirty="0"/>
+          </a:p>
+          <a:p>
+            <a:pPr marL="0" indent="0">
+              <a:buNone/>
+              <a:tabLst>
+                <a:tab pos="903243" algn="l"/>
+              </a:tabLst>
+            </a:pPr>
+            <a:endParaRPr lang="de-DE" sz="1400" dirty="0"/>
+          </a:p>
+        </p:txBody>
+      </p:sp>
+      <p:pic>
+        <p:nvPicPr>
+          <p:cNvPr id="7" name="Grafik 6"/>
+          <p:cNvPicPr>
+            <a:picLocks noChangeAspect="1"/>
+          </p:cNvPicPr>
+          <p:nvPr/>
+        </p:nvPicPr>
+        <p:blipFill>
+          <a:blip r:embed="rId6">
             <a:extLst>
-              <a:ext uri="{FF2B5EF4-FFF2-40B4-BE49-F238E27FC236}">
-                <a16:creationId xmlns:a16="http://schemas.microsoft.com/office/drawing/2014/main" id="{17123384-5C6E-A89F-65B9-F891A8EF59FC}"/>
+              <a:ext uri="{28A0092B-C50C-407E-A947-70E740481C1C}">
+                <a14:useLocalDpi xmlns:a14="http://schemas.microsoft.com/office/drawing/2010/main" val="0"/>
               </a:ext>
             </a:extLst>
-          </p:cNvPr>
-          <p:cNvSpPr txBox="1"/>
-          <p:nvPr/>
-        </p:nvSpPr>
+          </a:blip>
+          <a:stretch>
+            <a:fillRect/>
+          </a:stretch>
+        </p:blipFill>
         <p:spPr>
           <a:xfrm>
-            <a:off x="0" y="1002561"/>
-            <a:ext cx="12192000" cy="449675"/>
+            <a:off x="8544272" y="3494589"/>
+            <a:ext cx="1143000" cy="835819"/>
           </a:xfrm>
           <a:prstGeom prst="rect">
             <a:avLst/>
           </a:prstGeom>
-          <a:noFill/>
         </p:spPr>
-        <p:txBody>
-          <a:bodyPr wrap="square" lIns="391886" rtlCol="0">
-            <a:spAutoFit/>
-          </a:bodyPr>
-          <a:lstStyle/>
-          <a:p>
-            <a:r>
-              <a:rPr lang="en-GB" sz="2322" dirty="0">
-                <a:solidFill>
-                  <a:srgbClr val="262626"/>
-                </a:solidFill>
-                <a:latin typeface="Open Sans ExtraBold" pitchFamily="2" charset="0"/>
-                <a:ea typeface="Open Sans ExtraBold" pitchFamily="2" charset="0"/>
-                <a:cs typeface="Open Sans ExtraBold" pitchFamily="2" charset="0"/>
-              </a:rPr>
-              <a:t>Thank you for making this </a:t>
-            </a:r>
-            <a:r>
-              <a:rPr lang="en-GB" sz="2322" dirty="0">
-                <a:solidFill>
-                  <a:srgbClr val="31E2B7"/>
-                </a:solidFill>
-                <a:latin typeface="Open Sans ExtraBold" pitchFamily="2" charset="0"/>
-                <a:ea typeface="Open Sans ExtraBold" pitchFamily="2" charset="0"/>
-                <a:cs typeface="Open Sans ExtraBold" pitchFamily="2" charset="0"/>
-              </a:rPr>
-              <a:t>possible</a:t>
-            </a:r>
-            <a:endParaRPr lang="cs-CZ" sz="2322" dirty="0">
-              <a:solidFill>
-                <a:srgbClr val="31E2B7"/>
-              </a:solidFill>
-              <a:latin typeface="Open Sans ExtraBold" pitchFamily="2" charset="0"/>
-              <a:ea typeface="Open Sans ExtraBold" pitchFamily="2" charset="0"/>
-              <a:cs typeface="Open Sans ExtraBold" pitchFamily="2" charset="0"/>
-            </a:endParaRPr>
-          </a:p>
-        </p:txBody>
-      </p:sp>
-      <p:grpSp>
-        <p:nvGrpSpPr>
-          <p:cNvPr id="4" name="Skupina 3">
+      </p:pic>
+      <p:pic>
+        <p:nvPicPr>
+          <p:cNvPr id="8" name="Grafik 7"/>
+          <p:cNvPicPr>
+            <a:picLocks noChangeAspect="1"/>
+          </p:cNvPicPr>
+          <p:nvPr/>
+        </p:nvPicPr>
+        <p:blipFill>
+          <a:blip r:embed="rId7">
+            <a:extLst>
+              <a:ext uri="{28A0092B-C50C-407E-A947-70E740481C1C}">
+                <a14:useLocalDpi xmlns:a14="http://schemas.microsoft.com/office/drawing/2010/main" val="0"/>
+              </a:ext>
+            </a:extLst>
+          </a:blip>
+          <a:stretch>
+            <a:fillRect/>
+          </a:stretch>
+        </p:blipFill>
+        <p:spPr>
+          <a:xfrm>
+            <a:off x="9890472" y="3494589"/>
+            <a:ext cx="1143000" cy="857251"/>
+          </a:xfrm>
+          <a:prstGeom prst="rect">
+            <a:avLst/>
+          </a:prstGeom>
+        </p:spPr>
+      </p:pic>
+      <p:pic>
+        <p:nvPicPr>
+          <p:cNvPr id="9" name="Grafik 8"/>
+          <p:cNvPicPr>
+            <a:picLocks noChangeAspect="1"/>
+          </p:cNvPicPr>
+          <p:nvPr/>
+        </p:nvPicPr>
+        <p:blipFill>
+          <a:blip r:embed="rId8" cstate="print">
+            <a:extLst>
+              <a:ext uri="{28A0092B-C50C-407E-A947-70E740481C1C}">
+                <a14:useLocalDpi xmlns:a14="http://schemas.microsoft.com/office/drawing/2010/main" val="0"/>
+              </a:ext>
+            </a:extLst>
+          </a:blip>
+          <a:stretch>
+            <a:fillRect/>
+          </a:stretch>
+        </p:blipFill>
+        <p:spPr>
+          <a:xfrm>
+            <a:off x="8544273" y="4682333"/>
+            <a:ext cx="1458955" cy="598545"/>
+          </a:xfrm>
+          <a:prstGeom prst="rect">
+            <a:avLst/>
+          </a:prstGeom>
+        </p:spPr>
+      </p:pic>
+      <p:pic>
+        <p:nvPicPr>
+          <p:cNvPr id="5" name="Grafik 4" descr="Ein Bild, das Person, Mann, Brille, tragen enthält.&#10;&#10;Automatisch generierte Beschreibung">
             <a:extLst>
               <a:ext uri="{FF2B5EF4-FFF2-40B4-BE49-F238E27FC236}">
-                <a16:creationId xmlns:a16="http://schemas.microsoft.com/office/drawing/2014/main" id="{4CFF36D6-E223-09EB-5A01-02699D819CE4}"/>
+                <a16:creationId xmlns:a16="http://schemas.microsoft.com/office/drawing/2014/main" id="{46333317-A6F3-B2D3-B9F5-6B4A79A834BA}"/>
               </a:ext>
             </a:extLst>
           </p:cNvPr>
-          <p:cNvGrpSpPr>
-            <a:grpSpLocks noChangeAspect="1"/>
-          </p:cNvGrpSpPr>
+          <p:cNvPicPr>
+            <a:picLocks noChangeAspect="1"/>
+          </p:cNvPicPr>
           <p:nvPr/>
-        </p:nvGrpSpPr>
-        <p:grpSpPr>
-          <a:xfrm>
-            <a:off x="759116" y="2333625"/>
-            <a:ext cx="10673769" cy="2190750"/>
-            <a:chOff x="344233" y="2659885"/>
-            <a:chExt cx="8708701" cy="1787427"/>
-          </a:xfrm>
-        </p:grpSpPr>
-        <p:pic>
-          <p:nvPicPr>
-            <p:cNvPr id="7" name="Grafický objekt 6">
-              <a:extLst>
-                <a:ext uri="{FF2B5EF4-FFF2-40B4-BE49-F238E27FC236}">
-                  <a16:creationId xmlns:a16="http://schemas.microsoft.com/office/drawing/2014/main" id="{29AE14CB-EFA1-4849-7C29-09132615B933}"/>
-                </a:ext>
-              </a:extLst>
-            </p:cNvPr>
-            <p:cNvPicPr>
-              <a:picLocks noChangeAspect="1"/>
-            </p:cNvPicPr>
-            <p:nvPr/>
-          </p:nvPicPr>
-          <p:blipFill>
-            <a:blip>
-              <a:extLst>
-                <a:ext uri="{96DAC541-7B7A-43D3-8B79-37D633B846F1}">
-                  <asvg:svgBlip xmlns:asvg="http://schemas.microsoft.com/office/drawing/2016/SVG/main" r:embed="rId3"/>
-                </a:ext>
-              </a:extLst>
-            </a:blip>
-            <a:stretch>
-              <a:fillRect/>
-            </a:stretch>
-          </p:blipFill>
-          <p:spPr>
-            <a:xfrm>
-              <a:off x="3764040" y="2759719"/>
-              <a:ext cx="2287587" cy="487297"/>
-            </a:xfrm>
-            <a:prstGeom prst="rect">
-              <a:avLst/>
-            </a:prstGeom>
-          </p:spPr>
-        </p:pic>
-        <p:pic>
-          <p:nvPicPr>
-            <p:cNvPr id="13" name="Obrázek 12">
-              <a:extLst>
-                <a:ext uri="{FF2B5EF4-FFF2-40B4-BE49-F238E27FC236}">
-                  <a16:creationId xmlns:a16="http://schemas.microsoft.com/office/drawing/2014/main" id="{B0DC635E-DAFB-DA2D-8427-1D89B818CDC7}"/>
-                </a:ext>
-              </a:extLst>
-            </p:cNvPr>
-            <p:cNvPicPr>
-              <a:picLocks noChangeAspect="1"/>
-            </p:cNvPicPr>
-            <p:nvPr/>
-          </p:nvPicPr>
-          <p:blipFill>
-            <a:blip r:embed="rId4"/>
-            <a:stretch>
-              <a:fillRect/>
-            </a:stretch>
-          </p:blipFill>
-          <p:spPr>
-            <a:xfrm>
-              <a:off x="6561052" y="3957250"/>
-              <a:ext cx="588492" cy="258201"/>
-            </a:xfrm>
-            <a:prstGeom prst="rect">
-              <a:avLst/>
-            </a:prstGeom>
-          </p:spPr>
-        </p:pic>
-        <p:pic>
-          <p:nvPicPr>
-            <p:cNvPr id="14" name="Obrázek 13">
-              <a:extLst>
-                <a:ext uri="{FF2B5EF4-FFF2-40B4-BE49-F238E27FC236}">
-                  <a16:creationId xmlns:a16="http://schemas.microsoft.com/office/drawing/2014/main" id="{B545CA3A-CB53-3475-C707-FD6A7D132ACB}"/>
-                </a:ext>
-              </a:extLst>
-            </p:cNvPr>
-            <p:cNvPicPr>
-              <a:picLocks noChangeAspect="1"/>
-            </p:cNvPicPr>
-            <p:nvPr/>
-          </p:nvPicPr>
-          <p:blipFill>
-            <a:blip r:embed="rId5">
-              <a:extLst>
-                <a:ext uri="{28A0092B-C50C-407E-A947-70E740481C1C}">
-                  <a14:useLocalDpi xmlns:a14="http://schemas.microsoft.com/office/drawing/2010/main" val="0"/>
-                </a:ext>
-              </a:extLst>
-            </a:blip>
-            <a:stretch>
-              <a:fillRect/>
-            </a:stretch>
-          </p:blipFill>
-          <p:spPr>
-            <a:xfrm>
-              <a:off x="7910557" y="3966210"/>
-              <a:ext cx="1142377" cy="240281"/>
-            </a:xfrm>
-            <a:prstGeom prst="rect">
-              <a:avLst/>
-            </a:prstGeom>
-          </p:spPr>
-        </p:pic>
-        <p:pic>
-          <p:nvPicPr>
-            <p:cNvPr id="15" name="Grafický objekt 14">
-              <a:extLst>
-                <a:ext uri="{FF2B5EF4-FFF2-40B4-BE49-F238E27FC236}">
-                  <a16:creationId xmlns:a16="http://schemas.microsoft.com/office/drawing/2014/main" id="{1484C416-648F-EE19-9EA1-0613E4E69696}"/>
-                </a:ext>
-              </a:extLst>
-            </p:cNvPr>
-            <p:cNvPicPr>
-              <a:picLocks noChangeAspect="1"/>
-            </p:cNvPicPr>
-            <p:nvPr/>
-          </p:nvPicPr>
-          <p:blipFill>
-            <a:blip>
-              <a:extLst>
-                <a:ext uri="{96DAC541-7B7A-43D3-8B79-37D633B846F1}">
-                  <asvg:svgBlip xmlns:asvg="http://schemas.microsoft.com/office/drawing/2016/SVG/main" r:embed="rId6"/>
-                </a:ext>
-              </a:extLst>
-            </a:blip>
-            <a:stretch>
-              <a:fillRect/>
-            </a:stretch>
-          </p:blipFill>
-          <p:spPr>
-            <a:xfrm>
-              <a:off x="447609" y="3966210"/>
-              <a:ext cx="1263877" cy="240281"/>
-            </a:xfrm>
-            <a:prstGeom prst="rect">
-              <a:avLst/>
-            </a:prstGeom>
-          </p:spPr>
-        </p:pic>
-        <p:grpSp>
-          <p:nvGrpSpPr>
-            <p:cNvPr id="16" name="Skupina 15">
-              <a:extLst>
-                <a:ext uri="{FF2B5EF4-FFF2-40B4-BE49-F238E27FC236}">
-                  <a16:creationId xmlns:a16="http://schemas.microsoft.com/office/drawing/2014/main" id="{0A1C7BD6-EA0F-878F-4970-B1155EEF7A12}"/>
-                </a:ext>
-              </a:extLst>
-            </p:cNvPr>
-            <p:cNvGrpSpPr/>
-            <p:nvPr/>
-          </p:nvGrpSpPr>
-          <p:grpSpPr>
-            <a:xfrm>
-              <a:off x="344233" y="2659885"/>
-              <a:ext cx="1812854" cy="755356"/>
-              <a:chOff x="10239375" y="4953000"/>
-              <a:chExt cx="10287000" cy="4286250"/>
-            </a:xfrm>
-          </p:grpSpPr>
-          <p:sp>
-            <p:nvSpPr>
-              <p:cNvPr id="17" name="Obdélník: se zakulacenými rohy 16">
-                <a:extLst>
-                  <a:ext uri="{FF2B5EF4-FFF2-40B4-BE49-F238E27FC236}">
-                    <a16:creationId xmlns:a16="http://schemas.microsoft.com/office/drawing/2014/main" id="{54D43BDB-EEC2-B374-C913-327B64B91FF3}"/>
-                  </a:ext>
-                </a:extLst>
-              </p:cNvPr>
-              <p:cNvSpPr/>
-              <p:nvPr/>
-            </p:nvSpPr>
-            <p:spPr>
-              <a:xfrm>
-                <a:off x="10825978" y="5543550"/>
-                <a:ext cx="3109097" cy="3109101"/>
-              </a:xfrm>
-              <a:prstGeom prst="roundRect">
-                <a:avLst>
-                  <a:gd name="adj" fmla="val 6614"/>
-                </a:avLst>
-              </a:prstGeom>
-              <a:gradFill>
-                <a:gsLst>
-                  <a:gs pos="0">
-                    <a:srgbClr val="134C5E"/>
-                  </a:gs>
-                  <a:gs pos="47000">
-                    <a:srgbClr val="59AC57"/>
-                  </a:gs>
-                  <a:gs pos="100000">
-                    <a:srgbClr val="FFD400"/>
-                  </a:gs>
-                </a:gsLst>
-                <a:lin ang="0" scaled="0"/>
-              </a:gradFill>
-              <a:ln>
-                <a:noFill/>
-              </a:ln>
-            </p:spPr>
-            <p:style>
-              <a:lnRef idx="2">
-                <a:schemeClr val="accent1">
-                  <a:shade val="15000"/>
-                </a:schemeClr>
-              </a:lnRef>
-              <a:fillRef idx="1">
-                <a:schemeClr val="accent1"/>
-              </a:fillRef>
-              <a:effectRef idx="0">
-                <a:schemeClr val="accent1"/>
-              </a:effectRef>
-              <a:fontRef idx="minor">
-                <a:schemeClr val="lt1"/>
-              </a:fontRef>
-            </p:style>
-            <p:txBody>
-              <a:bodyPr rtlCol="0" anchor="ctr"/>
-              <a:lstStyle/>
-              <a:p>
-                <a:pPr algn="ctr"/>
-                <a:endParaRPr lang="cs-CZ" sz="435"/>
-              </a:p>
-            </p:txBody>
-          </p:sp>
-          <p:pic>
-            <p:nvPicPr>
-              <p:cNvPr id="18" name="Grafický objekt 17">
-                <a:extLst>
-                  <a:ext uri="{FF2B5EF4-FFF2-40B4-BE49-F238E27FC236}">
-                    <a16:creationId xmlns:a16="http://schemas.microsoft.com/office/drawing/2014/main" id="{0969CE4C-1D41-FD26-908B-B4C42D821272}"/>
-                  </a:ext>
-                </a:extLst>
-              </p:cNvPr>
-              <p:cNvPicPr>
-                <a:picLocks noChangeAspect="1"/>
-              </p:cNvPicPr>
-              <p:nvPr/>
-            </p:nvPicPr>
-            <p:blipFill>
-              <a:blip>
-                <a:extLst>
-                  <a:ext uri="{96DAC541-7B7A-43D3-8B79-37D633B846F1}">
-                    <asvg:svgBlip xmlns:asvg="http://schemas.microsoft.com/office/drawing/2016/SVG/main" r:embed="rId7"/>
-                  </a:ext>
-                </a:extLst>
-              </a:blip>
-              <a:stretch>
-                <a:fillRect/>
-              </a:stretch>
-            </p:blipFill>
-            <p:spPr>
-              <a:xfrm>
-                <a:off x="10239375" y="4953000"/>
-                <a:ext cx="10287000" cy="4286250"/>
-              </a:xfrm>
-              <a:prstGeom prst="rect">
-                <a:avLst/>
-              </a:prstGeom>
-            </p:spPr>
-          </p:pic>
-        </p:grpSp>
-        <p:pic>
-          <p:nvPicPr>
-            <p:cNvPr id="19" name="Obrázek 18">
-              <a:extLst>
-                <a:ext uri="{FF2B5EF4-FFF2-40B4-BE49-F238E27FC236}">
-                  <a16:creationId xmlns:a16="http://schemas.microsoft.com/office/drawing/2014/main" id="{5781FB30-B9EF-1227-805A-436F176D2843}"/>
-                </a:ext>
-              </a:extLst>
-            </p:cNvPr>
-            <p:cNvPicPr>
-              <a:picLocks noChangeAspect="1"/>
-            </p:cNvPicPr>
-            <p:nvPr/>
-          </p:nvPicPr>
-          <p:blipFill>
-            <a:blip r:embed="rId8">
-              <a:clrChange>
-                <a:clrFrom>
-                  <a:srgbClr val="FFFFFF"/>
-                </a:clrFrom>
-                <a:clrTo>
-                  <a:srgbClr val="FFFFFF">
-                    <a:alpha val="0"/>
-                  </a:srgbClr>
-                </a:clrTo>
-              </a:clrChange>
-              <a:extLst>
-                <a:ext uri="{28A0092B-C50C-407E-A947-70E740481C1C}">
-                  <a14:useLocalDpi xmlns:a14="http://schemas.microsoft.com/office/drawing/2010/main" val="0"/>
-                </a:ext>
-              </a:extLst>
-            </a:blip>
-            <a:stretch>
-              <a:fillRect/>
-            </a:stretch>
-          </p:blipFill>
-          <p:spPr>
-            <a:xfrm>
-              <a:off x="4356197" y="3725390"/>
-              <a:ext cx="1443843" cy="721922"/>
-            </a:xfrm>
-            <a:prstGeom prst="rect">
-              <a:avLst/>
-            </a:prstGeom>
-          </p:spPr>
-        </p:pic>
-        <p:pic>
-          <p:nvPicPr>
-            <p:cNvPr id="20" name="Obrázek 19">
-              <a:extLst>
-                <a:ext uri="{FF2B5EF4-FFF2-40B4-BE49-F238E27FC236}">
-                  <a16:creationId xmlns:a16="http://schemas.microsoft.com/office/drawing/2014/main" id="{9871F9B6-8460-302E-6E77-A53BAFCD5005}"/>
-                </a:ext>
-              </a:extLst>
-            </p:cNvPr>
-            <p:cNvPicPr>
-              <a:picLocks noChangeAspect="1"/>
-            </p:cNvPicPr>
-            <p:nvPr/>
-          </p:nvPicPr>
-          <p:blipFill>
-            <a:blip r:embed="rId9">
-              <a:clrChange>
-                <a:clrFrom>
-                  <a:srgbClr val="FFFEFF"/>
-                </a:clrFrom>
-                <a:clrTo>
-                  <a:srgbClr val="FFFEFF">
-                    <a:alpha val="0"/>
-                  </a:srgbClr>
-                </a:clrTo>
-              </a:clrChange>
-              <a:extLst>
-                <a:ext uri="{28A0092B-C50C-407E-A947-70E740481C1C}">
-                  <a14:useLocalDpi xmlns:a14="http://schemas.microsoft.com/office/drawing/2010/main" val="0"/>
-                </a:ext>
-              </a:extLst>
-            </a:blip>
-            <a:stretch>
-              <a:fillRect/>
-            </a:stretch>
-          </p:blipFill>
-          <p:spPr>
-            <a:xfrm>
-              <a:off x="7658581" y="2768985"/>
-              <a:ext cx="1394353" cy="488024"/>
-            </a:xfrm>
-            <a:prstGeom prst="rect">
-              <a:avLst/>
-            </a:prstGeom>
-          </p:spPr>
-        </p:pic>
-        <p:pic>
-          <p:nvPicPr>
-            <p:cNvPr id="21" name="Grafický objekt 20">
-              <a:extLst>
-                <a:ext uri="{FF2B5EF4-FFF2-40B4-BE49-F238E27FC236}">
-                  <a16:creationId xmlns:a16="http://schemas.microsoft.com/office/drawing/2014/main" id="{FB70BBA0-EB66-1592-65D9-947B1BA1A1E3}"/>
-                </a:ext>
-              </a:extLst>
-            </p:cNvPr>
-            <p:cNvPicPr>
-              <a:picLocks noChangeAspect="1"/>
-            </p:cNvPicPr>
-            <p:nvPr/>
-          </p:nvPicPr>
-          <p:blipFill>
-            <a:blip>
-              <a:extLst>
-                <a:ext uri="{96DAC541-7B7A-43D3-8B79-37D633B846F1}">
-                  <asvg:svgBlip xmlns:asvg="http://schemas.microsoft.com/office/drawing/2016/SVG/main" r:embed="rId10"/>
-                </a:ext>
-              </a:extLst>
-            </a:blip>
-            <a:srcRect/>
-            <a:stretch/>
-          </p:blipFill>
-          <p:spPr>
-            <a:xfrm>
-              <a:off x="2472499" y="3948384"/>
-              <a:ext cx="1122685" cy="275934"/>
-            </a:xfrm>
-            <a:prstGeom prst="rect">
-              <a:avLst/>
-            </a:prstGeom>
-          </p:spPr>
-        </p:pic>
-      </p:grpSp>
-      <p:grpSp>
-        <p:nvGrpSpPr>
-          <p:cNvPr id="5" name="Skupina 4">
+        </p:nvPicPr>
+        <p:blipFill rotWithShape="1">
+          <a:blip r:embed="rId9">
             <a:extLst>
-              <a:ext uri="{FF2B5EF4-FFF2-40B4-BE49-F238E27FC236}">
-                <a16:creationId xmlns:a16="http://schemas.microsoft.com/office/drawing/2014/main" id="{D9CD8D06-F0CE-B221-435B-A073E692347B}"/>
+              <a:ext uri="{28A0092B-C50C-407E-A947-70E740481C1C}">
+                <a14:useLocalDpi xmlns:a14="http://schemas.microsoft.com/office/drawing/2010/main" val="0"/>
               </a:ext>
             </a:extLst>
-          </p:cNvPr>
-          <p:cNvGrpSpPr/>
-          <p:nvPr/>
-        </p:nvGrpSpPr>
-        <p:grpSpPr>
+          </a:blip>
+          <a:srcRect l="38258"/>
+          <a:stretch/>
+        </p:blipFill>
+        <p:spPr>
           <a:xfrm>
-            <a:off x="8778418" y="5855439"/>
-            <a:ext cx="2654467" cy="360483"/>
-            <a:chOff x="1253980" y="5849691"/>
-            <a:chExt cx="2654467" cy="360483"/>
+            <a:off x="6499642" y="3429000"/>
+            <a:ext cx="1715073" cy="1851877"/>
           </a:xfrm>
-        </p:grpSpPr>
-        <p:sp>
-          <p:nvSpPr>
-            <p:cNvPr id="23" name="TextovéPole 22">
-              <a:extLst>
-                <a:ext uri="{FF2B5EF4-FFF2-40B4-BE49-F238E27FC236}">
-                  <a16:creationId xmlns:a16="http://schemas.microsoft.com/office/drawing/2014/main" id="{818533F6-BB21-AFBB-926D-BF8F0D9589DC}"/>
-                </a:ext>
-              </a:extLst>
-            </p:cNvPr>
-            <p:cNvSpPr txBox="1"/>
-            <p:nvPr/>
-          </p:nvSpPr>
-          <p:spPr>
-            <a:xfrm>
-              <a:off x="1253980" y="5849691"/>
-              <a:ext cx="2122325" cy="360483"/>
-            </a:xfrm>
-            <a:prstGeom prst="rect">
-              <a:avLst/>
-            </a:prstGeom>
-            <a:noFill/>
-          </p:spPr>
-          <p:txBody>
-            <a:bodyPr wrap="square">
-              <a:spAutoFit/>
-            </a:bodyPr>
-            <a:lstStyle/>
-            <a:p>
-              <a:pPr algn="r"/>
-              <a:r>
-                <a:rPr lang="cs-CZ" sz="581" b="1" dirty="0">
-                  <a:solidFill>
-                    <a:sysClr val="windowText" lastClr="000000"/>
-                  </a:solidFill>
-                  <a:latin typeface="Open Sans" pitchFamily="2" charset="0"/>
-                  <a:ea typeface="Open Sans" pitchFamily="2" charset="0"/>
-                  <a:cs typeface="Open Sans" pitchFamily="2" charset="0"/>
-                </a:rPr>
-                <a:t>28</a:t>
-              </a:r>
-              <a:r>
-                <a:rPr lang="en-GB" sz="581" b="1" dirty="0">
-                  <a:solidFill>
-                    <a:sysClr val="windowText" lastClr="000000"/>
-                  </a:solidFill>
-                  <a:latin typeface="Open Sans" pitchFamily="2" charset="0"/>
-                  <a:ea typeface="Open Sans" pitchFamily="2" charset="0"/>
-                  <a:cs typeface="Open Sans" pitchFamily="2" charset="0"/>
-                </a:rPr>
-                <a:t>&amp;</a:t>
-              </a:r>
-              <a:r>
-                <a:rPr lang="cs-CZ" sz="581" b="1" dirty="0">
-                  <a:solidFill>
-                    <a:sysClr val="windowText" lastClr="000000"/>
-                  </a:solidFill>
-                  <a:latin typeface="Open Sans" pitchFamily="2" charset="0"/>
-                  <a:ea typeface="Open Sans" pitchFamily="2" charset="0"/>
-                  <a:cs typeface="Open Sans" pitchFamily="2" charset="0"/>
-                </a:rPr>
-                <a:t>29 May 2026</a:t>
-              </a:r>
-            </a:p>
-            <a:p>
-              <a:pPr algn="r"/>
-              <a:r>
-                <a:rPr lang="cs-CZ" sz="581" dirty="0" err="1">
-                  <a:solidFill>
-                    <a:sysClr val="windowText" lastClr="000000"/>
-                  </a:solidFill>
-                  <a:latin typeface="Open Sans" pitchFamily="2" charset="0"/>
-                  <a:ea typeface="Open Sans" pitchFamily="2" charset="0"/>
-                  <a:cs typeface="Open Sans" pitchFamily="2" charset="0"/>
-                </a:rPr>
-                <a:t>Clarion</a:t>
-              </a:r>
-              <a:r>
-                <a:rPr lang="cs-CZ" sz="581" dirty="0">
-                  <a:solidFill>
-                    <a:sysClr val="windowText" lastClr="000000"/>
-                  </a:solidFill>
-                  <a:latin typeface="Open Sans" pitchFamily="2" charset="0"/>
-                  <a:ea typeface="Open Sans" pitchFamily="2" charset="0"/>
-                  <a:cs typeface="Open Sans" pitchFamily="2" charset="0"/>
-                </a:rPr>
-                <a:t> </a:t>
-              </a:r>
-              <a:r>
-                <a:rPr lang="cs-CZ" sz="581" dirty="0" err="1">
-                  <a:solidFill>
-                    <a:sysClr val="windowText" lastClr="000000"/>
-                  </a:solidFill>
-                  <a:latin typeface="Open Sans" pitchFamily="2" charset="0"/>
-                  <a:ea typeface="Open Sans" pitchFamily="2" charset="0"/>
-                  <a:cs typeface="Open Sans" pitchFamily="2" charset="0"/>
-                </a:rPr>
-                <a:t>Congress</a:t>
-              </a:r>
-              <a:r>
-                <a:rPr lang="cs-CZ" sz="581" dirty="0">
-                  <a:solidFill>
-                    <a:sysClr val="windowText" lastClr="000000"/>
-                  </a:solidFill>
-                  <a:latin typeface="Open Sans" pitchFamily="2" charset="0"/>
-                  <a:ea typeface="Open Sans" pitchFamily="2" charset="0"/>
-                  <a:cs typeface="Open Sans" pitchFamily="2" charset="0"/>
-                </a:rPr>
-                <a:t> Hotel Prague</a:t>
-              </a:r>
-            </a:p>
-            <a:p>
-              <a:pPr algn="r"/>
-              <a:r>
-                <a:rPr lang="cs-CZ" sz="581" dirty="0">
-                  <a:solidFill>
-                    <a:sysClr val="windowText" lastClr="000000"/>
-                  </a:solidFill>
-                  <a:latin typeface="Open Sans" pitchFamily="2" charset="0"/>
-                  <a:ea typeface="Open Sans" pitchFamily="2" charset="0"/>
-                  <a:cs typeface="Open Sans" pitchFamily="2" charset="0"/>
-                </a:rPr>
-                <a:t>CUBEX Centrum Prague</a:t>
-              </a:r>
-            </a:p>
-          </p:txBody>
-        </p:sp>
-        <p:pic>
-          <p:nvPicPr>
-            <p:cNvPr id="3" name="Grafický objekt 2">
-              <a:extLst>
-                <a:ext uri="{FF2B5EF4-FFF2-40B4-BE49-F238E27FC236}">
-                  <a16:creationId xmlns:a16="http://schemas.microsoft.com/office/drawing/2014/main" id="{F0D1B928-7099-B66D-AC6A-21C7D0DAEAE0}"/>
-                </a:ext>
-              </a:extLst>
-            </p:cNvPr>
-            <p:cNvPicPr>
-              <a:picLocks noChangeAspect="1"/>
-            </p:cNvPicPr>
-            <p:nvPr/>
-          </p:nvPicPr>
-          <p:blipFill>
-            <a:blip>
-              <a:extLst>
-                <a:ext uri="{96DAC541-7B7A-43D3-8B79-37D633B846F1}">
-                  <asvg:svgBlip xmlns:asvg="http://schemas.microsoft.com/office/drawing/2016/SVG/main" r:embed="rId11"/>
-                </a:ext>
-              </a:extLst>
-            </a:blip>
-            <a:srcRect r="81707" b="20678"/>
-            <a:stretch>
-              <a:fillRect/>
-            </a:stretch>
-          </p:blipFill>
-          <p:spPr>
-            <a:xfrm>
-              <a:off x="3481581" y="5849692"/>
-              <a:ext cx="426866" cy="290365"/>
-            </a:xfrm>
-            <a:prstGeom prst="rect">
-              <a:avLst/>
-            </a:prstGeom>
-          </p:spPr>
-        </p:pic>
-      </p:grpSp>
+          <a:prstGeom prst="rect">
+            <a:avLst/>
+          </a:prstGeom>
+        </p:spPr>
+      </p:pic>
     </p:spTree>
     <p:extLst>
       <p:ext uri="{BB962C8B-B14F-4D97-AF65-F5344CB8AC3E}">
-        <p14:creationId xmlns:p14="http://schemas.microsoft.com/office/powerpoint/2010/main" val="1665617814"/>
+        <p14:creationId xmlns:p14="http://schemas.microsoft.com/office/powerpoint/2010/main" val="1681187469"/>
       </p:ext>
     </p:extLst>
   </p:cSld>
@@ -7659,15 +6888,7 @@
           <a:p>
             <a:r>
               <a:rPr lang="en-US" dirty="0"/>
-              <a:t>Avoid </a:t>
-            </a:r>
-            <a:r>
-              <a:rPr lang="en-US" dirty="0" err="1"/>
-              <a:t>NONSargable</a:t>
-            </a:r>
-            <a:r>
-              <a:rPr lang="en-US" dirty="0"/>
-              <a:t> expressions and replace them with </a:t>
+              <a:t>Avoid NONSargable expressions and replace them with </a:t>
             </a:r>
             <a:r>
               <a:rPr lang="en-US" dirty="0" err="1"/>
@@ -7681,12 +6902,8 @@
               <a:rPr lang="en-US" dirty="0"/>
             </a:br>
             <a:r>
-              <a:rPr lang="en-US" dirty="0" err="1"/>
-              <a:t>NONSargable</a:t>
-            </a:r>
-            <a:r>
-              <a:rPr lang="en-US" dirty="0"/>
-              <a:t> expressions will lead to</a:t>
+              <a:rPr lang="en-US" dirty="0"/>
+              <a:t>NONSargable expressions will lead to</a:t>
             </a:r>
           </a:p>
           <a:p>
@@ -9894,7 +9111,15 @@
           <a:p>
             <a:r>
               <a:rPr lang="en-US" dirty="0"/>
-              <a:t>Scenario 2 – Problem Description</a:t>
+              <a:t>Scenario </a:t>
+            </a:r>
+            <a:r>
+              <a:rPr lang="en-US"/>
+              <a:t>3 - Problem </a:t>
+            </a:r>
+            <a:r>
+              <a:rPr lang="en-US" dirty="0"/>
+              <a:t>Description</a:t>
             </a:r>
           </a:p>
         </p:txBody>
@@ -11297,7 +10522,7 @@
       </p:grpSpPr>
       <p:sp>
         <p:nvSpPr>
-          <p:cNvPr id="4" name="Titel 3"/>
+          <p:cNvPr id="5" name="Titel 4"/>
           <p:cNvSpPr>
             <a:spLocks noGrp="1"/>
           </p:cNvSpPr>
@@ -11312,421 +10537,106 @@
           <a:p>
             <a:r>
               <a:rPr lang="de-DE" dirty="0"/>
-              <a:t>Uwe Ricken</a:t>
-            </a:r>
-            <a:br>
-              <a:rPr lang="de-DE" dirty="0"/>
-            </a:br>
-            <a:r>
-              <a:rPr lang="de-DE" sz="2400" dirty="0"/>
-              <a:t>db Berater GmbH</a:t>
+              <a:t>Break Times</a:t>
             </a:r>
           </a:p>
         </p:txBody>
       </p:sp>
       <p:sp>
         <p:nvSpPr>
-          <p:cNvPr id="2" name="Inhaltsplatzhalter 1"/>
+          <p:cNvPr id="6" name="Inhaltsplatzhalter 5"/>
           <p:cNvSpPr>
             <a:spLocks noGrp="1"/>
           </p:cNvSpPr>
           <p:nvPr>
-            <p:ph sz="half" idx="1"/>
+            <p:ph idx="1"/>
           </p:nvPr>
         </p:nvSpPr>
-        <p:spPr>
-          <a:prstGeom prst="rect">
-            <a:avLst/>
-          </a:prstGeom>
-        </p:spPr>
+        <p:spPr/>
         <p:txBody>
           <a:bodyPr>
             <a:normAutofit/>
           </a:bodyPr>
           <a:lstStyle/>
           <a:p>
-            <a:pPr marL="457166" lvl="1" indent="0">
-              <a:buNone/>
-            </a:pPr>
-            <a:r>
-              <a:rPr lang="en-US" sz="1400" dirty="0"/>
-              <a:t>I am working with IT-systems since early 1990's and with the main focus on </a:t>
-            </a:r>
-            <a:r>
-              <a:rPr lang="en-US" sz="1400" b="1" i="1" dirty="0">
-                <a:solidFill>
-                  <a:schemeClr val="accent5"/>
-                </a:solidFill>
-              </a:rPr>
-              <a:t>Microsoft SQL Server </a:t>
-            </a:r>
-            <a:r>
-              <a:rPr lang="en-US" sz="1400" dirty="0"/>
-              <a:t>since version 6.0. I started with development of database applications in 1998 with a professional CRM-System based on Microsoft products (Microsoft Office and </a:t>
-            </a:r>
-            <a:r>
-              <a:rPr lang="en-US" sz="1400" b="1" i="1" dirty="0">
-                <a:solidFill>
-                  <a:schemeClr val="accent5"/>
-                </a:solidFill>
-              </a:rPr>
-              <a:t>Microsoft SQL Server</a:t>
-            </a:r>
-            <a:r>
-              <a:rPr lang="en-US" sz="1400" dirty="0"/>
-              <a:t>).</a:t>
-            </a:r>
-          </a:p>
-          <a:p>
-            <a:pPr marL="457166" lvl="1" indent="0">
-              <a:buNone/>
-            </a:pPr>
+            <a:pPr lvl="1"/>
+            <a:r>
+              <a:rPr lang="de-DE" dirty="0"/>
+              <a:t>09:00 – 10:30		Session</a:t>
+            </a:r>
             <a:br>
-              <a:rPr lang="en-US" sz="1400" dirty="0"/>
+              <a:rPr lang="de-DE" dirty="0"/>
             </a:br>
-            <a:r>
-              <a:rPr lang="en-US" sz="1400" dirty="0"/>
-              <a:t>Since 2008 I'm focused exclusively on </a:t>
-            </a:r>
-            <a:r>
-              <a:rPr lang="en-US" sz="1400" b="1" i="1" dirty="0">
-                <a:solidFill>
-                  <a:schemeClr val="accent5"/>
-                </a:solidFill>
-              </a:rPr>
-              <a:t>Microsoft SQL Server</a:t>
-            </a:r>
-            <a:r>
-              <a:rPr lang="en-US" sz="1400" dirty="0"/>
-              <a:t> and I was working in 3rd level support teams for enterprise companies, banks and insurances.</a:t>
-            </a:r>
-          </a:p>
-          <a:p>
-            <a:pPr marL="457166" lvl="1" indent="0">
-              <a:buNone/>
-            </a:pPr>
-            <a:endParaRPr lang="en-US" sz="1400" dirty="0"/>
-          </a:p>
-          <a:p>
-            <a:pPr marL="457166" lvl="1" indent="0">
-              <a:buNone/>
-            </a:pPr>
-            <a:r>
-              <a:rPr lang="en-US" sz="1400" dirty="0"/>
-              <a:t>Since May 2013 I'm a </a:t>
-            </a:r>
-            <a:r>
-              <a:rPr lang="en-US" sz="1400" b="1" dirty="0">
-                <a:solidFill>
-                  <a:srgbClr val="FF0000"/>
-                </a:solidFill>
-              </a:rPr>
-              <a:t>Microsoft Certified Master: SQL Server 2008 </a:t>
-            </a:r>
-            <a:r>
-              <a:rPr lang="en-US" sz="1400" dirty="0"/>
-              <a:t>which was an amazing way into the depth of </a:t>
-            </a:r>
-            <a:r>
-              <a:rPr lang="en-US" sz="1400" b="1" i="1" dirty="0">
-                <a:solidFill>
-                  <a:schemeClr val="accent5"/>
-                </a:solidFill>
-              </a:rPr>
-              <a:t>Microsoft SQL Server</a:t>
-            </a:r>
-            <a:r>
-              <a:rPr lang="en-US" sz="1400" dirty="0"/>
-              <a:t>.</a:t>
-            </a:r>
-          </a:p>
-          <a:p>
-            <a:pPr marL="457166" lvl="1" indent="0">
-              <a:buNone/>
-            </a:pPr>
-            <a:endParaRPr lang="en-US" sz="1400" dirty="0"/>
-          </a:p>
-          <a:p>
-            <a:pPr marL="457166" lvl="1" indent="0">
-              <a:buNone/>
-            </a:pPr>
-            <a:r>
-              <a:rPr lang="en-US" sz="1400" dirty="0"/>
-              <a:t>In July 2013 I have been awarded with the MVP Award for </a:t>
-            </a:r>
-            <a:r>
-              <a:rPr lang="en-US" sz="1400" b="1" i="1" dirty="0">
-                <a:solidFill>
-                  <a:schemeClr val="accent5"/>
-                </a:solidFill>
-              </a:rPr>
-              <a:t>Microsoft SQL Server</a:t>
-            </a:r>
-            <a:r>
-              <a:rPr lang="en-US" sz="1400" dirty="0"/>
-              <a:t>.</a:t>
-            </a:r>
-            <a:endParaRPr lang="de-DE" sz="1400" dirty="0"/>
+            <a:endParaRPr lang="de-DE" dirty="0"/>
+          </a:p>
+          <a:p>
+            <a:pPr lvl="1"/>
+            <a:r>
+              <a:rPr lang="de-DE" dirty="0"/>
+              <a:t>10:30 – 11:00		Coffee Break</a:t>
+            </a:r>
+            <a:br>
+              <a:rPr lang="de-DE" dirty="0"/>
+            </a:br>
+            <a:endParaRPr lang="de-DE" dirty="0"/>
+          </a:p>
+          <a:p>
+            <a:pPr lvl="1"/>
+            <a:r>
+              <a:rPr lang="de-DE" dirty="0"/>
+              <a:t>11:00 – 12:30		Session</a:t>
+            </a:r>
+            <a:br>
+              <a:rPr lang="de-DE" dirty="0"/>
+            </a:br>
+            <a:endParaRPr lang="de-DE" dirty="0"/>
+          </a:p>
+          <a:p>
+            <a:pPr lvl="1"/>
+            <a:r>
+              <a:rPr lang="de-DE" dirty="0"/>
+              <a:t>12:30 – 13:30		Lunch Break</a:t>
+            </a:r>
+            <a:br>
+              <a:rPr lang="de-DE" dirty="0"/>
+            </a:br>
+            <a:endParaRPr lang="de-DE" dirty="0"/>
+          </a:p>
+          <a:p>
+            <a:pPr lvl="1"/>
+            <a:r>
+              <a:rPr lang="de-DE" dirty="0"/>
+              <a:t>13:30 – 15:00		Session</a:t>
+            </a:r>
+            <a:br>
+              <a:rPr lang="de-DE" dirty="0"/>
+            </a:br>
+            <a:endParaRPr lang="de-DE" dirty="0"/>
+          </a:p>
+          <a:p>
+            <a:pPr lvl="1"/>
+            <a:r>
+              <a:rPr lang="de-DE" dirty="0"/>
+              <a:t>15:00 – 15:30		Coffee Break</a:t>
+            </a:r>
+            <a:br>
+              <a:rPr lang="de-DE" dirty="0"/>
+            </a:br>
+            <a:endParaRPr lang="de-DE" dirty="0"/>
+          </a:p>
+          <a:p>
+            <a:pPr lvl="1"/>
+            <a:r>
+              <a:rPr lang="de-DE" dirty="0"/>
+              <a:t>15:30 – 16:45 / 17:00	Session</a:t>
+            </a:r>
           </a:p>
         </p:txBody>
       </p:sp>
-      <p:sp>
-        <p:nvSpPr>
-          <p:cNvPr id="6" name="Textplatzhalter 5"/>
-          <p:cNvSpPr>
-            <a:spLocks noGrp="1"/>
-          </p:cNvSpPr>
-          <p:nvPr>
-            <p:ph sz="half" idx="2"/>
-          </p:nvPr>
-        </p:nvSpPr>
-        <p:spPr>
-          <a:prstGeom prst="rect">
-            <a:avLst/>
-          </a:prstGeom>
-        </p:spPr>
-        <p:txBody>
-          <a:bodyPr>
-            <a:noAutofit/>
-          </a:bodyPr>
-          <a:lstStyle/>
-          <a:p>
-            <a:pPr marL="0" indent="0">
-              <a:buNone/>
-              <a:tabLst>
-                <a:tab pos="903243" algn="l"/>
-              </a:tabLst>
-            </a:pPr>
-            <a:r>
-              <a:rPr lang="de-DE" sz="1400" b="1" dirty="0" err="1"/>
-              <a:t>www</a:t>
-            </a:r>
-            <a:r>
-              <a:rPr lang="de-DE" sz="1400" dirty="0"/>
-              <a:t>:	</a:t>
-            </a:r>
-            <a:r>
-              <a:rPr lang="de-DE" sz="1400" dirty="0">
-                <a:hlinkClick r:id="rId2"/>
-              </a:rPr>
-              <a:t>http://www.db-berater.de</a:t>
-            </a:r>
-            <a:endParaRPr lang="de-DE" sz="1400" dirty="0"/>
-          </a:p>
-          <a:p>
-            <a:pPr marL="0" indent="0">
-              <a:buNone/>
-              <a:tabLst>
-                <a:tab pos="903243" algn="l"/>
-              </a:tabLst>
-            </a:pPr>
-            <a:r>
-              <a:rPr lang="de-DE" sz="1400" b="1" dirty="0"/>
-              <a:t>email</a:t>
-            </a:r>
-            <a:r>
-              <a:rPr lang="de-DE" sz="1400" dirty="0"/>
-              <a:t>:	</a:t>
-            </a:r>
-            <a:r>
-              <a:rPr lang="de-DE" sz="1400" dirty="0">
-                <a:hlinkClick r:id="rId3"/>
-              </a:rPr>
-              <a:t>uwe.ricken@db-berater.de</a:t>
-            </a:r>
-            <a:endParaRPr lang="de-DE" sz="1400" dirty="0"/>
-          </a:p>
-          <a:p>
-            <a:pPr marL="0" indent="0">
-              <a:buNone/>
-              <a:tabLst>
-                <a:tab pos="903243" algn="l"/>
-              </a:tabLst>
-            </a:pPr>
-            <a:r>
-              <a:rPr lang="de-DE" sz="1400" b="1" dirty="0" err="1"/>
-              <a:t>blog</a:t>
-            </a:r>
-            <a:r>
-              <a:rPr lang="de-DE" sz="1400" dirty="0"/>
-              <a:t>:	</a:t>
-            </a:r>
-            <a:r>
-              <a:rPr lang="de-DE" sz="1400" dirty="0">
-                <a:hlinkClick r:id="rId4"/>
-              </a:rPr>
-              <a:t>http://www.sqlmaster.de</a:t>
-            </a:r>
-            <a:endParaRPr lang="de-DE" sz="1400" dirty="0"/>
-          </a:p>
-          <a:p>
-            <a:pPr marL="0" indent="0">
-              <a:buNone/>
-              <a:tabLst>
-                <a:tab pos="903243" algn="l"/>
-              </a:tabLst>
-            </a:pPr>
-            <a:r>
-              <a:rPr lang="de-DE" sz="1400" dirty="0"/>
-              <a:t>LinkedIn:	</a:t>
-            </a:r>
-            <a:r>
-              <a:rPr lang="de-DE" sz="1400" dirty="0">
-                <a:hlinkClick r:id="rId5"/>
-              </a:rPr>
-              <a:t>https://www.linkedin.com/in/uwericken</a:t>
-            </a:r>
-            <a:endParaRPr lang="de-DE" sz="1400" dirty="0"/>
-          </a:p>
-          <a:p>
-            <a:pPr marL="0" indent="0">
-              <a:buNone/>
-              <a:tabLst>
-                <a:tab pos="903243" algn="l"/>
-              </a:tabLst>
-            </a:pPr>
-            <a:endParaRPr lang="de-DE" sz="1400" dirty="0"/>
-          </a:p>
-          <a:p>
-            <a:pPr marL="0" indent="0">
-              <a:buNone/>
-              <a:tabLst>
-                <a:tab pos="903243" algn="l"/>
-              </a:tabLst>
-            </a:pPr>
-            <a:endParaRPr lang="de-DE" sz="1400" dirty="0"/>
-          </a:p>
-        </p:txBody>
-      </p:sp>
-      <p:pic>
-        <p:nvPicPr>
-          <p:cNvPr id="7" name="Grafik 6"/>
-          <p:cNvPicPr>
-            <a:picLocks noChangeAspect="1"/>
-          </p:cNvPicPr>
-          <p:nvPr/>
-        </p:nvPicPr>
-        <p:blipFill>
-          <a:blip r:embed="rId6">
-            <a:extLst>
-              <a:ext uri="{28A0092B-C50C-407E-A947-70E740481C1C}">
-                <a14:useLocalDpi xmlns:a14="http://schemas.microsoft.com/office/drawing/2010/main" val="0"/>
-              </a:ext>
-            </a:extLst>
-          </a:blip>
-          <a:stretch>
-            <a:fillRect/>
-          </a:stretch>
-        </p:blipFill>
-        <p:spPr>
-          <a:xfrm>
-            <a:off x="8544272" y="3494589"/>
-            <a:ext cx="1143000" cy="835819"/>
-          </a:xfrm>
-          <a:prstGeom prst="rect">
-            <a:avLst/>
-          </a:prstGeom>
-        </p:spPr>
-      </p:pic>
-      <p:pic>
-        <p:nvPicPr>
-          <p:cNvPr id="8" name="Grafik 7"/>
-          <p:cNvPicPr>
-            <a:picLocks noChangeAspect="1"/>
-          </p:cNvPicPr>
-          <p:nvPr/>
-        </p:nvPicPr>
-        <p:blipFill>
-          <a:blip r:embed="rId7">
-            <a:extLst>
-              <a:ext uri="{28A0092B-C50C-407E-A947-70E740481C1C}">
-                <a14:useLocalDpi xmlns:a14="http://schemas.microsoft.com/office/drawing/2010/main" val="0"/>
-              </a:ext>
-            </a:extLst>
-          </a:blip>
-          <a:stretch>
-            <a:fillRect/>
-          </a:stretch>
-        </p:blipFill>
-        <p:spPr>
-          <a:xfrm>
-            <a:off x="9890472" y="3494589"/>
-            <a:ext cx="1143000" cy="857251"/>
-          </a:xfrm>
-          <a:prstGeom prst="rect">
-            <a:avLst/>
-          </a:prstGeom>
-        </p:spPr>
-      </p:pic>
-      <p:pic>
-        <p:nvPicPr>
-          <p:cNvPr id="9" name="Grafik 8"/>
-          <p:cNvPicPr>
-            <a:picLocks noChangeAspect="1"/>
-          </p:cNvPicPr>
-          <p:nvPr/>
-        </p:nvPicPr>
-        <p:blipFill>
-          <a:blip r:embed="rId8" cstate="print">
-            <a:extLst>
-              <a:ext uri="{28A0092B-C50C-407E-A947-70E740481C1C}">
-                <a14:useLocalDpi xmlns:a14="http://schemas.microsoft.com/office/drawing/2010/main" val="0"/>
-              </a:ext>
-            </a:extLst>
-          </a:blip>
-          <a:stretch>
-            <a:fillRect/>
-          </a:stretch>
-        </p:blipFill>
-        <p:spPr>
-          <a:xfrm>
-            <a:off x="8544273" y="4682333"/>
-            <a:ext cx="1458955" cy="598545"/>
-          </a:xfrm>
-          <a:prstGeom prst="rect">
-            <a:avLst/>
-          </a:prstGeom>
-        </p:spPr>
-      </p:pic>
-      <p:pic>
-        <p:nvPicPr>
-          <p:cNvPr id="5" name="Grafik 4" descr="Ein Bild, das Person, Mann, Brille, tragen enthält.&#10;&#10;Automatisch generierte Beschreibung">
-            <a:extLst>
-              <a:ext uri="{FF2B5EF4-FFF2-40B4-BE49-F238E27FC236}">
-                <a16:creationId xmlns:a16="http://schemas.microsoft.com/office/drawing/2014/main" id="{46333317-A6F3-B2D3-B9F5-6B4A79A834BA}"/>
-              </a:ext>
-            </a:extLst>
-          </p:cNvPr>
-          <p:cNvPicPr>
-            <a:picLocks noChangeAspect="1"/>
-          </p:cNvPicPr>
-          <p:nvPr/>
-        </p:nvPicPr>
-        <p:blipFill rotWithShape="1">
-          <a:blip r:embed="rId9">
-            <a:extLst>
-              <a:ext uri="{28A0092B-C50C-407E-A947-70E740481C1C}">
-                <a14:useLocalDpi xmlns:a14="http://schemas.microsoft.com/office/drawing/2010/main" val="0"/>
-              </a:ext>
-            </a:extLst>
-          </a:blip>
-          <a:srcRect l="38258"/>
-          <a:stretch/>
-        </p:blipFill>
-        <p:spPr>
-          <a:xfrm>
-            <a:off x="6499642" y="3429000"/>
-            <a:ext cx="1715073" cy="1851877"/>
-          </a:xfrm>
-          <a:prstGeom prst="rect">
-            <a:avLst/>
-          </a:prstGeom>
-        </p:spPr>
-      </p:pic>
     </p:spTree>
     <p:extLst>
       <p:ext uri="{BB962C8B-B14F-4D97-AF65-F5344CB8AC3E}">
-        <p14:creationId xmlns:p14="http://schemas.microsoft.com/office/powerpoint/2010/main" val="1681187469"/>
+        <p14:creationId xmlns:p14="http://schemas.microsoft.com/office/powerpoint/2010/main" val="3203706696"/>
       </p:ext>
     </p:extLst>
   </p:cSld>
@@ -14858,149 +13768,6 @@
       </p:grpSpPr>
       <p:sp>
         <p:nvSpPr>
-          <p:cNvPr id="5" name="Titel 4"/>
-          <p:cNvSpPr>
-            <a:spLocks noGrp="1"/>
-          </p:cNvSpPr>
-          <p:nvPr>
-            <p:ph type="title"/>
-          </p:nvPr>
-        </p:nvSpPr>
-        <p:spPr/>
-        <p:txBody>
-          <a:bodyPr/>
-          <a:lstStyle/>
-          <a:p>
-            <a:r>
-              <a:rPr lang="de-DE" dirty="0"/>
-              <a:t>Break Times</a:t>
-            </a:r>
-          </a:p>
-        </p:txBody>
-      </p:sp>
-      <p:sp>
-        <p:nvSpPr>
-          <p:cNvPr id="6" name="Inhaltsplatzhalter 5"/>
-          <p:cNvSpPr>
-            <a:spLocks noGrp="1"/>
-          </p:cNvSpPr>
-          <p:nvPr>
-            <p:ph idx="1"/>
-          </p:nvPr>
-        </p:nvSpPr>
-        <p:spPr/>
-        <p:txBody>
-          <a:bodyPr>
-            <a:normAutofit/>
-          </a:bodyPr>
-          <a:lstStyle/>
-          <a:p>
-            <a:pPr lvl="1"/>
-            <a:r>
-              <a:rPr lang="de-DE" dirty="0"/>
-              <a:t>09:00 – 10:30		Session</a:t>
-            </a:r>
-            <a:br>
-              <a:rPr lang="de-DE" dirty="0"/>
-            </a:br>
-            <a:endParaRPr lang="de-DE" dirty="0"/>
-          </a:p>
-          <a:p>
-            <a:pPr lvl="1"/>
-            <a:r>
-              <a:rPr lang="de-DE" dirty="0"/>
-              <a:t>10:30 – 11:00		Coffee Break</a:t>
-            </a:r>
-            <a:br>
-              <a:rPr lang="de-DE" dirty="0"/>
-            </a:br>
-            <a:endParaRPr lang="de-DE" dirty="0"/>
-          </a:p>
-          <a:p>
-            <a:pPr lvl="1"/>
-            <a:r>
-              <a:rPr lang="de-DE" dirty="0"/>
-              <a:t>11:00 – 12:30		Session</a:t>
-            </a:r>
-            <a:br>
-              <a:rPr lang="de-DE" dirty="0"/>
-            </a:br>
-            <a:endParaRPr lang="de-DE" dirty="0"/>
-          </a:p>
-          <a:p>
-            <a:pPr lvl="1"/>
-            <a:r>
-              <a:rPr lang="de-DE" dirty="0"/>
-              <a:t>12:30 – 13:30		Lunch Break</a:t>
-            </a:r>
-            <a:br>
-              <a:rPr lang="de-DE" dirty="0"/>
-            </a:br>
-            <a:endParaRPr lang="de-DE" dirty="0"/>
-          </a:p>
-          <a:p>
-            <a:pPr lvl="1"/>
-            <a:r>
-              <a:rPr lang="de-DE" dirty="0"/>
-              <a:t>13:30 – 15:00		Session</a:t>
-            </a:r>
-            <a:br>
-              <a:rPr lang="de-DE" dirty="0"/>
-            </a:br>
-            <a:endParaRPr lang="de-DE" dirty="0"/>
-          </a:p>
-          <a:p>
-            <a:pPr lvl="1"/>
-            <a:r>
-              <a:rPr lang="de-DE" dirty="0"/>
-              <a:t>15:00 – 15:30		Coffee Break</a:t>
-            </a:r>
-            <a:br>
-              <a:rPr lang="de-DE" dirty="0"/>
-            </a:br>
-            <a:endParaRPr lang="de-DE" dirty="0"/>
-          </a:p>
-          <a:p>
-            <a:pPr lvl="1"/>
-            <a:r>
-              <a:rPr lang="de-DE" dirty="0"/>
-              <a:t>15:30 – 16:45 / 17:00	Session</a:t>
-            </a:r>
-          </a:p>
-        </p:txBody>
-      </p:sp>
-    </p:spTree>
-    <p:extLst>
-      <p:ext uri="{BB962C8B-B14F-4D97-AF65-F5344CB8AC3E}">
-        <p14:creationId xmlns:p14="http://schemas.microsoft.com/office/powerpoint/2010/main" val="3203706696"/>
-      </p:ext>
-    </p:extLst>
-  </p:cSld>
-  <p:clrMapOvr>
-    <a:masterClrMapping/>
-  </p:clrMapOvr>
-</p:sld>
-</file>
-
-<file path=ppt/slides/slide5.xml><?xml version="1.0" encoding="utf-8"?>
-<p:sld xmlns:a="http://schemas.openxmlformats.org/drawingml/2006/main" xmlns:r="http://schemas.openxmlformats.org/officeDocument/2006/relationships" xmlns:p="http://schemas.openxmlformats.org/presentationml/2006/main">
-  <p:cSld>
-    <p:spTree>
-      <p:nvGrpSpPr>
-        <p:cNvPr id="1" name=""/>
-        <p:cNvGrpSpPr/>
-        <p:nvPr/>
-      </p:nvGrpSpPr>
-      <p:grpSpPr>
-        <a:xfrm>
-          <a:off x="0" y="0"/>
-          <a:ext cx="0" cy="0"/>
-          <a:chOff x="0" y="0"/>
-          <a:chExt cx="0" cy="0"/>
-        </a:xfrm>
-      </p:grpSpPr>
-      <p:sp>
-        <p:nvSpPr>
           <p:cNvPr id="2" name="Titel 1">
             <a:extLst>
               <a:ext uri="{FF2B5EF4-FFF2-40B4-BE49-F238E27FC236}">
@@ -15074,7 +13841,7 @@
               <a:rPr lang="en-US" sz="1600" dirty="0">
                 <a:hlinkClick r:id="rId2"/>
               </a:rPr>
-              <a:t>https://www.db-berater.de/downloads/ERP_DEMO_2012.BAK</a:t>
+              <a:t>https://www.db-berater.de/downloads/ERP_DEMO.BAK</a:t>
             </a:r>
             <a:endParaRPr lang="en-US" sz="1600" dirty="0"/>
           </a:p>
@@ -15379,7 +14146,7 @@
 </p:sld>
 </file>
 
-<file path=ppt/slides/slide6.xml><?xml version="1.0" encoding="utf-8"?>
+<file path=ppt/slides/slide5.xml><?xml version="1.0" encoding="utf-8"?>
 <p:sld xmlns:a="http://schemas.openxmlformats.org/drawingml/2006/main" xmlns:r="http://schemas.openxmlformats.org/officeDocument/2006/relationships" xmlns:p="http://schemas.openxmlformats.org/presentationml/2006/main">
   <p:cSld>
     <p:spTree>
@@ -15596,7 +14363,7 @@
 </p:sld>
 </file>
 
-<file path=ppt/slides/slide7.xml><?xml version="1.0" encoding="utf-8"?>
+<file path=ppt/slides/slide6.xml><?xml version="1.0" encoding="utf-8"?>
 <p:sld xmlns:a="http://schemas.openxmlformats.org/drawingml/2006/main" xmlns:r="http://schemas.openxmlformats.org/officeDocument/2006/relationships" xmlns:p="http://schemas.openxmlformats.org/presentationml/2006/main">
   <p:cSld>
     <p:spTree>
@@ -15744,7 +14511,7 @@
 </p:sld>
 </file>
 
-<file path=ppt/slides/slide8.xml><?xml version="1.0" encoding="utf-8"?>
+<file path=ppt/slides/slide7.xml><?xml version="1.0" encoding="utf-8"?>
 <p:sld xmlns:a="http://schemas.openxmlformats.org/drawingml/2006/main" xmlns:r="http://schemas.openxmlformats.org/officeDocument/2006/relationships" xmlns:p="http://schemas.openxmlformats.org/presentationml/2006/main">
   <p:cSld>
     <p:spTree>
@@ -15882,6 +14649,100 @@
     <p:extLst>
       <p:ext uri="{BB962C8B-B14F-4D97-AF65-F5344CB8AC3E}">
         <p14:creationId xmlns:p14="http://schemas.microsoft.com/office/powerpoint/2010/main" val="793187785"/>
+      </p:ext>
+    </p:extLst>
+  </p:cSld>
+  <p:clrMapOvr>
+    <a:masterClrMapping/>
+  </p:clrMapOvr>
+</p:sld>
+</file>
+
+<file path=ppt/slides/slide8.xml><?xml version="1.0" encoding="utf-8"?>
+<p:sld xmlns:a="http://schemas.openxmlformats.org/drawingml/2006/main" xmlns:r="http://schemas.openxmlformats.org/officeDocument/2006/relationships" xmlns:p="http://schemas.openxmlformats.org/presentationml/2006/main">
+  <p:cSld>
+    <p:spTree>
+      <p:nvGrpSpPr>
+        <p:cNvPr id="1" name=""/>
+        <p:cNvGrpSpPr/>
+        <p:nvPr/>
+      </p:nvGrpSpPr>
+      <p:grpSpPr>
+        <a:xfrm>
+          <a:off x="0" y="0"/>
+          <a:ext cx="0" cy="0"/>
+          <a:chOff x="0" y="0"/>
+          <a:chExt cx="0" cy="0"/>
+        </a:xfrm>
+      </p:grpSpPr>
+      <p:sp>
+        <p:nvSpPr>
+          <p:cNvPr id="4" name="Titel 3">
+            <a:extLst>
+              <a:ext uri="{FF2B5EF4-FFF2-40B4-BE49-F238E27FC236}">
+                <a16:creationId xmlns:a16="http://schemas.microsoft.com/office/drawing/2014/main" id="{A5EF6EA5-108D-9347-5C58-BB99DC3C7928}"/>
+              </a:ext>
+            </a:extLst>
+          </p:cNvPr>
+          <p:cNvSpPr>
+            <a:spLocks noGrp="1"/>
+          </p:cNvSpPr>
+          <p:nvPr>
+            <p:ph type="ctrTitle"/>
+          </p:nvPr>
+        </p:nvSpPr>
+        <p:spPr/>
+        <p:txBody>
+          <a:bodyPr/>
+          <a:lstStyle/>
+          <a:p>
+            <a:r>
+              <a:rPr lang="en-US" dirty="0"/>
+              <a:t>Tools </a:t>
+            </a:r>
+            <a:r>
+              <a:rPr lang="en-US" dirty="0" err="1"/>
+              <a:t>ans</a:t>
+            </a:r>
+            <a:r>
+              <a:rPr lang="en-US" dirty="0"/>
+              <a:t> Best Practices</a:t>
+            </a:r>
+          </a:p>
+        </p:txBody>
+      </p:sp>
+      <p:sp>
+        <p:nvSpPr>
+          <p:cNvPr id="5" name="Untertitel 4">
+            <a:extLst>
+              <a:ext uri="{FF2B5EF4-FFF2-40B4-BE49-F238E27FC236}">
+                <a16:creationId xmlns:a16="http://schemas.microsoft.com/office/drawing/2014/main" id="{DD464124-FF31-3B4B-1D83-054518A9DD4B}"/>
+              </a:ext>
+            </a:extLst>
+          </p:cNvPr>
+          <p:cNvSpPr>
+            <a:spLocks noGrp="1"/>
+          </p:cNvSpPr>
+          <p:nvPr>
+            <p:ph type="subTitle" idx="1"/>
+          </p:nvPr>
+        </p:nvSpPr>
+        <p:spPr/>
+        <p:txBody>
+          <a:bodyPr/>
+          <a:lstStyle/>
+          <a:p>
+            <a:r>
+              <a:rPr lang="en-US" dirty="0"/>
+              <a:t>The survival kit for developers who inherited ‘legacy’ SQL</a:t>
+            </a:r>
+          </a:p>
+        </p:txBody>
+      </p:sp>
+    </p:spTree>
+    <p:extLst>
+      <p:ext uri="{BB962C8B-B14F-4D97-AF65-F5344CB8AC3E}">
+        <p14:creationId xmlns:p14="http://schemas.microsoft.com/office/powerpoint/2010/main" val="542850919"/>
       </p:ext>
     </p:extLst>
   </p:cSld>

</xml_diff>

<commit_message>
rework of scenario #2 and scenario #3
</commit_message>
<xml_diff>
--- a/01 - Documents and Preparation/Accelerate your T-SQL Code.pptx
+++ b/01 - Documents and Preparation/Accelerate your T-SQL Code.pptx
@@ -154,7 +154,7 @@
 <file path=ppt/revisionInfo.xml><?xml version="1.0" encoding="utf-8"?>
 <p1510:revInfo xmlns:a="http://schemas.openxmlformats.org/drawingml/2006/main" xmlns:r="http://schemas.openxmlformats.org/officeDocument/2006/relationships" xmlns:p1510="http://schemas.microsoft.com/office/powerpoint/2015/10/main">
   <p1510:revLst>
-    <p1510:client id="{B4A5CE1A-760E-4FE6-9DA0-4AA372CE281A}" v="2" dt="2026-09-21T08:08:55.453"/>
+    <p1510:client id="{B4A5CE1A-760E-4FE6-9DA0-4AA372CE281A}" v="3" dt="2026-09-21T12:11:28.642"/>
   </p1510:revLst>
 </p1510:revInfo>
 </file>
@@ -164,7 +164,7 @@
   <pc:docChgLst>
     <pc:chgData name="Uwe Ricken" userId="f02567aecbed924b" providerId="LiveId" clId="{E77B627B-1F43-41A9-9F24-D4BB31BF6050}"/>
     <pc:docChg chg="undo custSel addSld delSld modSld">
-      <pc:chgData name="Uwe Ricken" userId="f02567aecbed924b" providerId="LiveId" clId="{E77B627B-1F43-41A9-9F24-D4BB31BF6050}" dt="2026-09-21T07:57:24.855" v="983" actId="20577"/>
+      <pc:chgData name="Uwe Ricken" userId="f02567aecbed924b" providerId="LiveId" clId="{E77B627B-1F43-41A9-9F24-D4BB31BF6050}" dt="2026-09-21T12:11:55.816" v="1080" actId="20577"/>
       <pc:docMkLst>
         <pc:docMk/>
       </pc:docMkLst>
@@ -180,6 +180,66 @@
             <pc:docMk/>
             <pc:sldMk cId="1275382174" sldId="346"/>
             <ac:spMk id="3" creationId="{3A8154F0-962D-21DD-4A9F-7CFF4A489FD1}"/>
+          </ac:spMkLst>
+        </pc:spChg>
+      </pc:sldChg>
+      <pc:sldChg chg="modSp mod">
+        <pc:chgData name="Uwe Ricken" userId="f02567aecbed924b" providerId="LiveId" clId="{E77B627B-1F43-41A9-9F24-D4BB31BF6050}" dt="2026-09-21T08:48:24.240" v="987" actId="20577"/>
+        <pc:sldMkLst>
+          <pc:docMk/>
+          <pc:sldMk cId="4257262995" sldId="353"/>
+        </pc:sldMkLst>
+        <pc:spChg chg="mod">
+          <ac:chgData name="Uwe Ricken" userId="f02567aecbed924b" providerId="LiveId" clId="{E77B627B-1F43-41A9-9F24-D4BB31BF6050}" dt="2026-09-21T08:48:24.240" v="987" actId="20577"/>
+          <ac:spMkLst>
+            <pc:docMk/>
+            <pc:sldMk cId="4257262995" sldId="353"/>
+            <ac:spMk id="3" creationId="{11457BA8-2A88-3CC3-2BE1-F8EB62F45485}"/>
+          </ac:spMkLst>
+        </pc:spChg>
+      </pc:sldChg>
+      <pc:sldChg chg="modSp mod">
+        <pc:chgData name="Uwe Ricken" userId="f02567aecbed924b" providerId="LiveId" clId="{E77B627B-1F43-41A9-9F24-D4BB31BF6050}" dt="2026-09-21T11:01:06.229" v="1017" actId="20577"/>
+        <pc:sldMkLst>
+          <pc:docMk/>
+          <pc:sldMk cId="1962351292" sldId="354"/>
+        </pc:sldMkLst>
+        <pc:spChg chg="mod">
+          <ac:chgData name="Uwe Ricken" userId="f02567aecbed924b" providerId="LiveId" clId="{E77B627B-1F43-41A9-9F24-D4BB31BF6050}" dt="2026-09-21T11:01:06.229" v="1017" actId="20577"/>
+          <ac:spMkLst>
+            <pc:docMk/>
+            <pc:sldMk cId="1962351292" sldId="354"/>
+            <ac:spMk id="3" creationId="{5C8F06CD-AD14-C7A2-6EF4-9CFDE74DFCE9}"/>
+          </ac:spMkLst>
+        </pc:spChg>
+      </pc:sldChg>
+      <pc:sldChg chg="modSp mod">
+        <pc:chgData name="Uwe Ricken" userId="f02567aecbed924b" providerId="LiveId" clId="{E77B627B-1F43-41A9-9F24-D4BB31BF6050}" dt="2026-09-21T12:10:44.881" v="1047" actId="20577"/>
+        <pc:sldMkLst>
+          <pc:docMk/>
+          <pc:sldMk cId="3871746749" sldId="357"/>
+        </pc:sldMkLst>
+        <pc:spChg chg="mod">
+          <ac:chgData name="Uwe Ricken" userId="f02567aecbed924b" providerId="LiveId" clId="{E77B627B-1F43-41A9-9F24-D4BB31BF6050}" dt="2026-09-21T12:10:44.881" v="1047" actId="20577"/>
+          <ac:spMkLst>
+            <pc:docMk/>
+            <pc:sldMk cId="3871746749" sldId="357"/>
+            <ac:spMk id="5" creationId="{689B48F3-0D30-D9A3-9590-0A7145158651}"/>
+          </ac:spMkLst>
+        </pc:spChg>
+      </pc:sldChg>
+      <pc:sldChg chg="modSp mod">
+        <pc:chgData name="Uwe Ricken" userId="f02567aecbed924b" providerId="LiveId" clId="{E77B627B-1F43-41A9-9F24-D4BB31BF6050}" dt="2026-09-21T12:11:55.816" v="1080" actId="20577"/>
+        <pc:sldMkLst>
+          <pc:docMk/>
+          <pc:sldMk cId="2669480126" sldId="392"/>
+        </pc:sldMkLst>
+        <pc:spChg chg="mod">
+          <ac:chgData name="Uwe Ricken" userId="f02567aecbed924b" providerId="LiveId" clId="{E77B627B-1F43-41A9-9F24-D4BB31BF6050}" dt="2026-09-21T12:11:55.816" v="1080" actId="20577"/>
+          <ac:spMkLst>
+            <pc:docMk/>
+            <pc:sldMk cId="2669480126" sldId="392"/>
+            <ac:spMk id="3" creationId="{ED40C9EC-951A-8100-AD1B-EB8F8E41094F}"/>
           </ac:spMkLst>
         </pc:spChg>
       </pc:sldChg>
@@ -7195,7 +7255,7 @@
             <a:pPr lvl="1"/>
             <a:r>
               <a:rPr lang="en-US" sz="1600" dirty="0"/>
-              <a:t>The table is growing the system suffers from performance problems.</a:t>
+              <a:t>The table is growing and the system suffers from performance problems.</a:t>
             </a:r>
           </a:p>
         </p:txBody>
@@ -8619,62 +8679,86 @@
             <a:pPr lvl="1"/>
             <a:r>
               <a:rPr lang="en-US" dirty="0"/>
-              <a:t>A stored procedure [</a:t>
-            </a:r>
-            <a:r>
-              <a:rPr lang="en-US" dirty="0" err="1"/>
+              <a:t>A stored procedure </a:t>
+            </a:r>
+            <a:r>
+              <a:rPr lang="en-US" b="1" dirty="0"/>
+              <a:t>[</a:t>
+            </a:r>
+            <a:r>
+              <a:rPr lang="en-US" b="1" dirty="0" err="1"/>
               <a:t>dbo</a:t>
             </a:r>
             <a:r>
-              <a:rPr lang="en-US" dirty="0"/>
+              <a:rPr lang="en-US" b="1" dirty="0"/>
               <a:t>].[</a:t>
             </a:r>
             <a:r>
-              <a:rPr lang="en-US" dirty="0" err="1"/>
+              <a:rPr lang="en-US" b="1" dirty="0" err="1"/>
               <a:t>jobqueue_delete</a:t>
             </a:r>
             <a:r>
-              <a:rPr lang="en-US" dirty="0"/>
-              <a:t>] handles the maintenance of the </a:t>
-            </a:r>
-            <a:r>
-              <a:rPr lang="en-US" dirty="0" err="1"/>
-              <a:t>the</a:t>
-            </a:r>
-            <a:r>
-              <a:rPr lang="en-US" dirty="0"/>
-              <a:t> table [</a:t>
-            </a:r>
-            <a:r>
-              <a:rPr lang="en-US" dirty="0" err="1"/>
+              <a:rPr lang="en-US" b="1" dirty="0"/>
+              <a:t>]</a:t>
+            </a:r>
+            <a:r>
+              <a:rPr lang="en-US" dirty="0"/>
+              <a:t> handles the maintenance of the table </a:t>
+            </a:r>
+            <a:r>
+              <a:rPr lang="en-US" b="1" dirty="0"/>
+              <a:t>[</a:t>
+            </a:r>
+            <a:r>
+              <a:rPr lang="en-US" b="1" dirty="0" err="1"/>
               <a:t>dbo</a:t>
             </a:r>
             <a:r>
-              <a:rPr lang="en-US" dirty="0"/>
+              <a:rPr lang="en-US" b="1" dirty="0"/>
               <a:t>].[</a:t>
             </a:r>
             <a:r>
-              <a:rPr lang="en-US" dirty="0" err="1"/>
+              <a:rPr lang="en-US" b="1" dirty="0" err="1"/>
               <a:t>jobqueue</a:t>
             </a:r>
             <a:r>
-              <a:rPr lang="en-US" dirty="0"/>
-              <a:t>].</a:t>
+              <a:rPr lang="en-US" b="1" dirty="0"/>
+              <a:t>]</a:t>
+            </a:r>
+            <a:r>
+              <a:rPr lang="en-US" dirty="0"/>
+              <a:t>.</a:t>
             </a:r>
           </a:p>
           <a:p>
             <a:pPr lvl="1"/>
             <a:r>
               <a:rPr lang="en-US" dirty="0"/>
-              <a:t>The table [</a:t>
-            </a:r>
-            <a:r>
-              <a:rPr lang="en-US" dirty="0" err="1"/>
+              <a:t>The table </a:t>
+            </a:r>
+            <a:r>
+              <a:rPr lang="en-US" b="1" dirty="0"/>
+              <a:t>[</a:t>
+            </a:r>
+            <a:r>
+              <a:rPr lang="en-US" b="1" dirty="0" err="1"/>
               <a:t>dbo</a:t>
             </a:r>
             <a:r>
-              <a:rPr lang="en-US" dirty="0"/>
-              <a:t>].[runtimes] stores the measures after each improvement.</a:t>
+              <a:rPr lang="en-US" b="1" dirty="0"/>
+              <a:t>].[</a:t>
+            </a:r>
+            <a:r>
+              <a:rPr lang="en-US" b="1" dirty="0" err="1"/>
+              <a:t>runtime_statistics</a:t>
+            </a:r>
+            <a:r>
+              <a:rPr lang="en-US" b="1" dirty="0"/>
+              <a:t>]</a:t>
+            </a:r>
+            <a:r>
+              <a:rPr lang="en-US" dirty="0"/>
+              <a:t> stores the measures after each improvement.</a:t>
             </a:r>
           </a:p>
           <a:p>
@@ -9047,7 +9131,7 @@
           <a:p>
             <a:r>
               <a:rPr lang="en-US" dirty="0"/>
-              <a:t>Stop using table variables and temporary objects</a:t>
+              <a:t>When Indexes won’t work</a:t>
             </a:r>
           </a:p>
         </p:txBody>
@@ -10353,63 +10437,37 @@
             <a:pPr lvl="1"/>
             <a:r>
               <a:rPr lang="en-US" dirty="0"/>
-              <a:t>A stored procedure [</a:t>
-            </a:r>
-            <a:r>
-              <a:rPr lang="en-US" dirty="0" err="1"/>
+              <a:t>A stored procedure </a:t>
+            </a:r>
+            <a:r>
+              <a:rPr lang="en-US" b="1" dirty="0"/>
+              <a:t>[</a:t>
+            </a:r>
+            <a:r>
+              <a:rPr lang="en-US" b="1" dirty="0" err="1"/>
               <a:t>dbo</a:t>
             </a:r>
             <a:r>
-              <a:rPr lang="en-US" dirty="0"/>
+              <a:rPr lang="en-US" b="1" dirty="0"/>
               <a:t>].[</a:t>
             </a:r>
             <a:r>
-              <a:rPr lang="en-US" dirty="0" err="1"/>
-              <a:t>jobqueue_delete</a:t>
-            </a:r>
-            <a:r>
-              <a:rPr lang="en-US" dirty="0"/>
-              <a:t>] handles the maintenance of the </a:t>
-            </a:r>
-            <a:r>
-              <a:rPr lang="en-US" dirty="0" err="1"/>
-              <a:t>the</a:t>
-            </a:r>
-            <a:r>
-              <a:rPr lang="en-US" dirty="0"/>
-              <a:t> table [</a:t>
-            </a:r>
-            <a:r>
-              <a:rPr lang="en-US" dirty="0" err="1"/>
-              <a:t>dbo</a:t>
-            </a:r>
-            <a:r>
-              <a:rPr lang="en-US" dirty="0"/>
-              <a:t>].[</a:t>
-            </a:r>
-            <a:r>
-              <a:rPr lang="en-US" dirty="0" err="1"/>
-              <a:t>jobqueue</a:t>
-            </a:r>
-            <a:r>
-              <a:rPr lang="en-US" dirty="0"/>
-              <a:t>].</a:t>
-            </a:r>
-          </a:p>
-          <a:p>
-            <a:pPr lvl="1"/>
-            <a:r>
-              <a:rPr lang="en-US" dirty="0"/>
-              <a:t>The table [</a:t>
-            </a:r>
-            <a:r>
-              <a:rPr lang="en-US" dirty="0" err="1"/>
-              <a:t>dbo</a:t>
-            </a:r>
-            <a:r>
-              <a:rPr lang="en-US" dirty="0"/>
-              <a:t>].[runtimes] stores the measures after each improvement.</a:t>
-            </a:r>
+              <a:rPr lang="en-US" b="1" dirty="0" err="1"/>
+              <a:t>dbo.stress_query</a:t>
+            </a:r>
+            <a:r>
+              <a:rPr lang="en-US" b="1" dirty="0"/>
+              <a:t>]</a:t>
+            </a:r>
+            <a:r>
+              <a:rPr lang="en-US" dirty="0"/>
+              <a:t> is used to stress </a:t>
+            </a:r>
+            <a:r>
+              <a:rPr lang="en-US"/>
+              <a:t>the database.</a:t>
+            </a:r>
+            <a:endParaRPr lang="en-US" dirty="0"/>
           </a:p>
           <a:p>
             <a:r>

</xml_diff>